<commit_message>
Implement TODO v3.1 overlay refactor
</commit_message>
<xml_diff>
--- a/plugins/codex/plugins/presentations/shared/templates/cuhk/pptx/cuhk-reference-deck.pptx
+++ b/plugins/codex/plugins/presentations/shared/templates/cuhk/pptx/cuhk-reference-deck.pptx
@@ -8,6 +8,15 @@
     <p:sldId id="256" r:id="rId7"/>
     <p:sldId id="257" r:id="rId8"/>
     <p:sldId id="258" r:id="rId9"/>
+    <p:sldId id="259" r:id="rId10"/>
+    <p:sldId id="260" r:id="rId11"/>
+    <p:sldId id="261" r:id="rId12"/>
+    <p:sldId id="262" r:id="rId13"/>
+    <p:sldId id="263" r:id="rId14"/>
+    <p:sldId id="264" r:id="rId15"/>
+    <p:sldId id="265" r:id="rId16"/>
+    <p:sldId id="266" r:id="rId17"/>
+    <p:sldId id="267" r:id="rId18"/>
   </p:sldIdLst>
   <p:sldSz cx="12191695" cy="6858000" type="screen4x3"/>
   <p:notesSz cx="6858000" cy="9144000"/>
@@ -3287,6 +3296,659 @@
 </p:sld>
 </file>
 
+<file path=ppt/slides/slide10.xml><?xml version="1.0" encoding="utf-8"?>
+<p:sld xmlns:a="http://schemas.openxmlformats.org/drawingml/2006/main" xmlns:p="http://schemas.openxmlformats.org/presentationml/2006/main" xmlns:r="http://schemas.openxmlformats.org/officeDocument/2006/relationships">
+  <p:cSld>
+    <p:spTree>
+      <p:nvGrpSpPr>
+        <p:cNvPr id="1" name=""/>
+        <p:cNvGrpSpPr/>
+        <p:nvPr/>
+      </p:nvGrpSpPr>
+      <p:grpSpPr/>
+      <p:sp>
+        <p:nvSpPr>
+          <p:cNvPr id="2" name="Rectangle 1"/>
+          <p:cNvSpPr/>
+          <p:nvPr/>
+        </p:nvSpPr>
+        <p:spPr>
+          <a:xfrm>
+            <a:off x="0" y="0"/>
+            <a:ext cx="12191695" cy="384048"/>
+          </a:xfrm>
+          <a:prstGeom prst="rect">
+            <a:avLst/>
+          </a:prstGeom>
+          <a:solidFill>
+            <a:srgbClr val="72256D"/>
+          </a:solidFill>
+          <a:ln>
+            <a:noFill/>
+          </a:ln>
+        </p:spPr>
+        <p:style>
+          <a:lnRef idx="1">
+            <a:schemeClr val="accent1"/>
+          </a:lnRef>
+          <a:fillRef idx="3">
+            <a:schemeClr val="accent1"/>
+          </a:fillRef>
+          <a:effectRef idx="2">
+            <a:schemeClr val="accent1"/>
+          </a:effectRef>
+          <a:fontRef idx="minor">
+            <a:schemeClr val="lt1"/>
+          </a:fontRef>
+        </p:style>
+        <p:txBody>
+          <a:bodyPr rtlCol="0" anchor="ctr"/>
+          <a:lstStyle/>
+          <a:p>
+            <a:pPr algn="ctr"/>
+          </a:p>
+        </p:txBody>
+      </p:sp>
+      <p:sp>
+        <p:nvSpPr>
+          <p:cNvPr id="3" name="TextBox 2"/>
+          <p:cNvSpPr txBox="1"/>
+          <p:nvPr/>
+        </p:nvSpPr>
+        <p:spPr>
+          <a:xfrm>
+            <a:off x="411480" y="73152"/>
+            <a:ext cx="6858000" cy="228600"/>
+          </a:xfrm>
+          <a:prstGeom prst="rect">
+            <a:avLst/>
+          </a:prstGeom>
+          <a:noFill/>
+        </p:spPr>
+        <p:txBody>
+          <a:bodyPr wrap="none">
+            <a:spAutoFit/>
+          </a:bodyPr>
+          <a:lstStyle/>
+          <a:p>
+            <a:r>
+              <a:rPr sz="900" b="0">
+                <a:solidFill>
+                  <a:srgbClr val="FFFFFF"/>
+                </a:solidFill>
+                <a:latin typeface="Aptos"/>
+              </a:rPr>
+              <a:t>Appendix</a:t>
+            </a:r>
+          </a:p>
+        </p:txBody>
+      </p:sp>
+      <p:sp>
+        <p:nvSpPr>
+          <p:cNvPr id="4" name="TextBox 3"/>
+          <p:cNvSpPr txBox="1"/>
+          <p:nvPr/>
+        </p:nvSpPr>
+        <p:spPr>
+          <a:xfrm>
+            <a:off x="10607040" y="73152"/>
+            <a:ext cx="1097280" cy="228600"/>
+          </a:xfrm>
+          <a:prstGeom prst="rect">
+            <a:avLst/>
+          </a:prstGeom>
+          <a:noFill/>
+        </p:spPr>
+        <p:txBody>
+          <a:bodyPr wrap="none">
+            <a:spAutoFit/>
+          </a:bodyPr>
+          <a:lstStyle/>
+          <a:p>
+            <a:r>
+              <a:rPr sz="900" b="0">
+                <a:solidFill>
+                  <a:srgbClr val="FFFFFF"/>
+                </a:solidFill>
+                <a:latin typeface="Aptos"/>
+              </a:rPr>
+              <a:t>10</a:t>
+            </a:r>
+          </a:p>
+        </p:txBody>
+      </p:sp>
+      <p:sp>
+        <p:nvSpPr>
+          <p:cNvPr id="5" name="TextBox 4"/>
+          <p:cNvSpPr txBox="1"/>
+          <p:nvPr/>
+        </p:nvSpPr>
+        <p:spPr>
+          <a:xfrm>
+            <a:off x="594360" y="658368"/>
+            <a:ext cx="9875520" cy="502920"/>
+          </a:xfrm>
+          <a:prstGeom prst="rect">
+            <a:avLst/>
+          </a:prstGeom>
+          <a:noFill/>
+        </p:spPr>
+        <p:txBody>
+          <a:bodyPr wrap="none">
+            <a:spAutoFit/>
+          </a:bodyPr>
+          <a:lstStyle/>
+          <a:p>
+            <a:r>
+              <a:rPr sz="2800" b="1">
+                <a:solidFill>
+                  <a:srgbClr val="201A2A"/>
+                </a:solidFill>
+                <a:latin typeface="Aptos"/>
+              </a:rPr>
+              <a:t>References</a:t>
+            </a:r>
+          </a:p>
+        </p:txBody>
+      </p:sp>
+      <p:sp>
+        <p:nvSpPr>
+          <p:cNvPr id="6" name="TextBox 5"/>
+          <p:cNvSpPr txBox="1"/>
+          <p:nvPr/>
+        </p:nvSpPr>
+        <p:spPr>
+          <a:xfrm>
+            <a:off x="822960" y="1417320"/>
+            <a:ext cx="9875520" cy="3474720"/>
+          </a:xfrm>
+          <a:prstGeom prst="rect">
+            <a:avLst/>
+          </a:prstGeom>
+          <a:noFill/>
+        </p:spPr>
+        <p:txBody>
+          <a:bodyPr wrap="none">
+            <a:spAutoFit/>
+          </a:bodyPr>
+          <a:lstStyle/>
+          <a:p>
+            <a:pPr>
+              <a:defRPr sz="1500">
+                <a:solidFill>
+                  <a:srgbClr val="201A2A"/>
+                </a:solidFill>
+                <a:latin typeface="Aptos"/>
+              </a:defRPr>
+            </a:pPr>
+            <a:r>
+              <a:t>[1] Source paper or dataset</a:t>
+            </a:r>
+          </a:p>
+          <a:p>
+            <a:pPr>
+              <a:defRPr sz="1500">
+                <a:solidFill>
+                  <a:srgbClr val="201A2A"/>
+                </a:solidFill>
+                <a:latin typeface="Aptos"/>
+              </a:defRPr>
+            </a:pPr>
+            <a:r>
+              <a:t>[2] Repository result artifact</a:t>
+            </a:r>
+          </a:p>
+          <a:p>
+            <a:pPr>
+              <a:defRPr sz="1500">
+                <a:solidFill>
+                  <a:srgbClr val="201A2A"/>
+                </a:solidFill>
+                <a:latin typeface="Aptos"/>
+              </a:defRPr>
+            </a:pPr>
+            <a:r>
+              <a:t>[3] Review note or issue</a:t>
+            </a:r>
+          </a:p>
+        </p:txBody>
+      </p:sp>
+    </p:spTree>
+  </p:cSld>
+  <p:clrMapOvr>
+    <a:masterClrMapping/>
+  </p:clrMapOvr>
+</p:sld>
+</file>
+
+<file path=ppt/slides/slide11.xml><?xml version="1.0" encoding="utf-8"?>
+<p:sld xmlns:a="http://schemas.openxmlformats.org/drawingml/2006/main" xmlns:p="http://schemas.openxmlformats.org/presentationml/2006/main" xmlns:r="http://schemas.openxmlformats.org/officeDocument/2006/relationships">
+  <p:cSld>
+    <p:spTree>
+      <p:nvGrpSpPr>
+        <p:cNvPr id="1" name=""/>
+        <p:cNvGrpSpPr/>
+        <p:nvPr/>
+      </p:nvGrpSpPr>
+      <p:grpSpPr/>
+      <p:sp>
+        <p:nvSpPr>
+          <p:cNvPr id="2" name="Rectangle 1"/>
+          <p:cNvSpPr/>
+          <p:nvPr/>
+        </p:nvSpPr>
+        <p:spPr>
+          <a:xfrm>
+            <a:off x="0" y="0"/>
+            <a:ext cx="12191695" cy="384048"/>
+          </a:xfrm>
+          <a:prstGeom prst="rect">
+            <a:avLst/>
+          </a:prstGeom>
+          <a:solidFill>
+            <a:srgbClr val="72256D"/>
+          </a:solidFill>
+          <a:ln>
+            <a:noFill/>
+          </a:ln>
+        </p:spPr>
+        <p:style>
+          <a:lnRef idx="1">
+            <a:schemeClr val="accent1"/>
+          </a:lnRef>
+          <a:fillRef idx="3">
+            <a:schemeClr val="accent1"/>
+          </a:fillRef>
+          <a:effectRef idx="2">
+            <a:schemeClr val="accent1"/>
+          </a:effectRef>
+          <a:fontRef idx="minor">
+            <a:schemeClr val="lt1"/>
+          </a:fontRef>
+        </p:style>
+        <p:txBody>
+          <a:bodyPr rtlCol="0" anchor="ctr"/>
+          <a:lstStyle/>
+          <a:p>
+            <a:pPr algn="ctr"/>
+          </a:p>
+        </p:txBody>
+      </p:sp>
+      <p:sp>
+        <p:nvSpPr>
+          <p:cNvPr id="3" name="TextBox 2"/>
+          <p:cNvSpPr txBox="1"/>
+          <p:nvPr/>
+        </p:nvSpPr>
+        <p:spPr>
+          <a:xfrm>
+            <a:off x="411480" y="73152"/>
+            <a:ext cx="6858000" cy="228600"/>
+          </a:xfrm>
+          <a:prstGeom prst="rect">
+            <a:avLst/>
+          </a:prstGeom>
+          <a:noFill/>
+        </p:spPr>
+        <p:txBody>
+          <a:bodyPr wrap="none">
+            <a:spAutoFit/>
+          </a:bodyPr>
+          <a:lstStyle/>
+          <a:p>
+            <a:r>
+              <a:rPr sz="900" b="0">
+                <a:solidFill>
+                  <a:srgbClr val="FFFFFF"/>
+                </a:solidFill>
+                <a:latin typeface="Aptos"/>
+              </a:rPr>
+              <a:t>Backup</a:t>
+            </a:r>
+          </a:p>
+        </p:txBody>
+      </p:sp>
+      <p:sp>
+        <p:nvSpPr>
+          <p:cNvPr id="4" name="TextBox 3"/>
+          <p:cNvSpPr txBox="1"/>
+          <p:nvPr/>
+        </p:nvSpPr>
+        <p:spPr>
+          <a:xfrm>
+            <a:off x="10607040" y="73152"/>
+            <a:ext cx="1097280" cy="228600"/>
+          </a:xfrm>
+          <a:prstGeom prst="rect">
+            <a:avLst/>
+          </a:prstGeom>
+          <a:noFill/>
+        </p:spPr>
+        <p:txBody>
+          <a:bodyPr wrap="none">
+            <a:spAutoFit/>
+          </a:bodyPr>
+          <a:lstStyle/>
+          <a:p>
+            <a:r>
+              <a:rPr sz="900" b="0">
+                <a:solidFill>
+                  <a:srgbClr val="FFFFFF"/>
+                </a:solidFill>
+                <a:latin typeface="Aptos"/>
+              </a:rPr>
+              <a:t>11</a:t>
+            </a:r>
+          </a:p>
+        </p:txBody>
+      </p:sp>
+      <p:sp>
+        <p:nvSpPr>
+          <p:cNvPr id="5" name="TextBox 4"/>
+          <p:cNvSpPr txBox="1"/>
+          <p:nvPr/>
+        </p:nvSpPr>
+        <p:spPr>
+          <a:xfrm>
+            <a:off x="594360" y="658368"/>
+            <a:ext cx="9875520" cy="502920"/>
+          </a:xfrm>
+          <a:prstGeom prst="rect">
+            <a:avLst/>
+          </a:prstGeom>
+          <a:noFill/>
+        </p:spPr>
+        <p:txBody>
+          <a:bodyPr wrap="none">
+            <a:spAutoFit/>
+          </a:bodyPr>
+          <a:lstStyle/>
+          <a:p>
+            <a:r>
+              <a:rPr sz="2800" b="1">
+                <a:solidFill>
+                  <a:srgbClr val="201A2A"/>
+                </a:solidFill>
+                <a:latin typeface="Aptos"/>
+              </a:rPr>
+              <a:t>Backup Detail</a:t>
+            </a:r>
+          </a:p>
+        </p:txBody>
+      </p:sp>
+      <p:sp>
+        <p:nvSpPr>
+          <p:cNvPr id="6" name="TextBox 5"/>
+          <p:cNvSpPr txBox="1"/>
+          <p:nvPr/>
+        </p:nvSpPr>
+        <p:spPr>
+          <a:xfrm>
+            <a:off x="822960" y="1554480"/>
+            <a:ext cx="9509760" cy="1097280"/>
+          </a:xfrm>
+          <a:prstGeom prst="rect">
+            <a:avLst/>
+          </a:prstGeom>
+          <a:noFill/>
+        </p:spPr>
+        <p:txBody>
+          <a:bodyPr wrap="none">
+            <a:spAutoFit/>
+          </a:bodyPr>
+          <a:lstStyle/>
+          <a:p>
+            <a:r>
+              <a:rPr sz="1800" b="0">
+                <a:solidFill>
+                  <a:srgbClr val="201A2A"/>
+                </a:solidFill>
+                <a:latin typeface="Aptos"/>
+              </a:rPr>
+              <a:t>Use backup slides for sensitivity analysis, extra tables, or reproducibility details that should not interrupt the main talk.</a:t>
+            </a:r>
+          </a:p>
+        </p:txBody>
+      </p:sp>
+    </p:spTree>
+  </p:cSld>
+  <p:clrMapOvr>
+    <a:masterClrMapping/>
+  </p:clrMapOvr>
+</p:sld>
+</file>
+
+<file path=ppt/slides/slide12.xml><?xml version="1.0" encoding="utf-8"?>
+<p:sld xmlns:a="http://schemas.openxmlformats.org/drawingml/2006/main" xmlns:p="http://schemas.openxmlformats.org/presentationml/2006/main" xmlns:r="http://schemas.openxmlformats.org/officeDocument/2006/relationships">
+  <p:cSld>
+    <p:spTree>
+      <p:nvGrpSpPr>
+        <p:cNvPr id="1" name=""/>
+        <p:cNvGrpSpPr/>
+        <p:nvPr/>
+      </p:nvGrpSpPr>
+      <p:grpSpPr/>
+      <p:sp>
+        <p:nvSpPr>
+          <p:cNvPr id="2" name="Rectangle 1"/>
+          <p:cNvSpPr/>
+          <p:nvPr/>
+        </p:nvSpPr>
+        <p:spPr>
+          <a:xfrm>
+            <a:off x="0" y="0"/>
+            <a:ext cx="12191695" cy="384048"/>
+          </a:xfrm>
+          <a:prstGeom prst="rect">
+            <a:avLst/>
+          </a:prstGeom>
+          <a:solidFill>
+            <a:srgbClr val="72256D"/>
+          </a:solidFill>
+          <a:ln>
+            <a:noFill/>
+          </a:ln>
+        </p:spPr>
+        <p:style>
+          <a:lnRef idx="1">
+            <a:schemeClr val="accent1"/>
+          </a:lnRef>
+          <a:fillRef idx="3">
+            <a:schemeClr val="accent1"/>
+          </a:fillRef>
+          <a:effectRef idx="2">
+            <a:schemeClr val="accent1"/>
+          </a:effectRef>
+          <a:fontRef idx="minor">
+            <a:schemeClr val="lt1"/>
+          </a:fontRef>
+        </p:style>
+        <p:txBody>
+          <a:bodyPr rtlCol="0" anchor="ctr"/>
+          <a:lstStyle/>
+          <a:p>
+            <a:pPr algn="ctr"/>
+          </a:p>
+        </p:txBody>
+      </p:sp>
+      <p:sp>
+        <p:nvSpPr>
+          <p:cNvPr id="3" name="TextBox 2"/>
+          <p:cNvSpPr txBox="1"/>
+          <p:nvPr/>
+        </p:nvSpPr>
+        <p:spPr>
+          <a:xfrm>
+            <a:off x="411480" y="73152"/>
+            <a:ext cx="6858000" cy="228600"/>
+          </a:xfrm>
+          <a:prstGeom prst="rect">
+            <a:avLst/>
+          </a:prstGeom>
+          <a:noFill/>
+        </p:spPr>
+        <p:txBody>
+          <a:bodyPr wrap="none">
+            <a:spAutoFit/>
+          </a:bodyPr>
+          <a:lstStyle/>
+          <a:p>
+            <a:r>
+              <a:rPr sz="900" b="0">
+                <a:solidFill>
+                  <a:srgbClr val="FFFFFF"/>
+                </a:solidFill>
+                <a:latin typeface="Aptos"/>
+              </a:rPr>
+              <a:t>Closing</a:t>
+            </a:r>
+          </a:p>
+        </p:txBody>
+      </p:sp>
+      <p:sp>
+        <p:nvSpPr>
+          <p:cNvPr id="4" name="TextBox 3"/>
+          <p:cNvSpPr txBox="1"/>
+          <p:nvPr/>
+        </p:nvSpPr>
+        <p:spPr>
+          <a:xfrm>
+            <a:off x="10607040" y="73152"/>
+            <a:ext cx="1097280" cy="228600"/>
+          </a:xfrm>
+          <a:prstGeom prst="rect">
+            <a:avLst/>
+          </a:prstGeom>
+          <a:noFill/>
+        </p:spPr>
+        <p:txBody>
+          <a:bodyPr wrap="none">
+            <a:spAutoFit/>
+          </a:bodyPr>
+          <a:lstStyle/>
+          <a:p>
+            <a:r>
+              <a:rPr sz="900" b="0">
+                <a:solidFill>
+                  <a:srgbClr val="FFFFFF"/>
+                </a:solidFill>
+                <a:latin typeface="Aptos"/>
+              </a:rPr>
+              <a:t>12</a:t>
+            </a:r>
+          </a:p>
+        </p:txBody>
+      </p:sp>
+      <p:sp>
+        <p:nvSpPr>
+          <p:cNvPr id="5" name="TextBox 4"/>
+          <p:cNvSpPr txBox="1"/>
+          <p:nvPr/>
+        </p:nvSpPr>
+        <p:spPr>
+          <a:xfrm>
+            <a:off x="594360" y="658368"/>
+            <a:ext cx="9875520" cy="502920"/>
+          </a:xfrm>
+          <a:prstGeom prst="rect">
+            <a:avLst/>
+          </a:prstGeom>
+          <a:noFill/>
+        </p:spPr>
+        <p:txBody>
+          <a:bodyPr wrap="none">
+            <a:spAutoFit/>
+          </a:bodyPr>
+          <a:lstStyle/>
+          <a:p>
+            <a:r>
+              <a:rPr sz="2800" b="1">
+                <a:solidFill>
+                  <a:srgbClr val="201A2A"/>
+                </a:solidFill>
+                <a:latin typeface="Aptos"/>
+              </a:rPr>
+              <a:t>Thank You</a:t>
+            </a:r>
+          </a:p>
+        </p:txBody>
+      </p:sp>
+      <p:sp>
+        <p:nvSpPr>
+          <p:cNvPr id="6" name="TextBox 5"/>
+          <p:cNvSpPr txBox="1"/>
+          <p:nvPr/>
+        </p:nvSpPr>
+        <p:spPr>
+          <a:xfrm>
+            <a:off x="822960" y="2194560"/>
+            <a:ext cx="6400800" cy="731520"/>
+          </a:xfrm>
+          <a:prstGeom prst="rect">
+            <a:avLst/>
+          </a:prstGeom>
+          <a:noFill/>
+        </p:spPr>
+        <p:txBody>
+          <a:bodyPr wrap="none">
+            <a:spAutoFit/>
+          </a:bodyPr>
+          <a:lstStyle/>
+          <a:p>
+            <a:r>
+              <a:rPr sz="3400" b="1">
+                <a:solidFill>
+                  <a:srgbClr val="72256D"/>
+                </a:solidFill>
+                <a:latin typeface="Aptos"/>
+              </a:rPr>
+              <a:t>Discussion</a:t>
+            </a:r>
+          </a:p>
+        </p:txBody>
+      </p:sp>
+      <p:sp>
+        <p:nvSpPr>
+          <p:cNvPr id="7" name="TextBox 6"/>
+          <p:cNvSpPr txBox="1"/>
+          <p:nvPr/>
+        </p:nvSpPr>
+        <p:spPr>
+          <a:xfrm>
+            <a:off x="841248" y="3063240"/>
+            <a:ext cx="7315200" cy="457200"/>
+          </a:xfrm>
+          <a:prstGeom prst="rect">
+            <a:avLst/>
+          </a:prstGeom>
+          <a:noFill/>
+        </p:spPr>
+        <p:txBody>
+          <a:bodyPr wrap="none">
+            <a:spAutoFit/>
+          </a:bodyPr>
+          <a:lstStyle/>
+          <a:p>
+            <a:r>
+              <a:rPr sz="1800" b="0">
+                <a:solidFill>
+                  <a:srgbClr val="201A2A"/>
+                </a:solidFill>
+                <a:latin typeface="Aptos"/>
+              </a:rPr>
+              <a:t>Questions, next decisions, or contact information.</a:t>
+            </a:r>
+          </a:p>
+        </p:txBody>
+      </p:sp>
+    </p:spTree>
+  </p:cSld>
+  <p:clrMapOvr>
+    <a:masterClrMapping/>
+  </p:clrMapOvr>
+</p:sld>
+</file>
+
 <file path=ppt/slides/slide2.xml><?xml version="1.0" encoding="utf-8"?>
 <p:sld xmlns:a="http://schemas.openxmlformats.org/drawingml/2006/main" xmlns:p="http://schemas.openxmlformats.org/presentationml/2006/main" xmlns:r="http://schemas.openxmlformats.org/officeDocument/2006/relationships">
   <p:cSld>
@@ -3679,7 +4341,7 @@
                 </a:solidFill>
                 <a:latin typeface="Aptos"/>
               </a:rPr>
-              <a:t>Closing</a:t>
+              <a:t>Background</a:t>
             </a:r>
           </a:p>
         </p:txBody>
@@ -3747,7 +4409,7 @@
                 </a:solidFill>
                 <a:latin typeface="Aptos"/>
               </a:rPr>
-              <a:t>Thank You</a:t>
+              <a:t>Research Question</a:t>
             </a:r>
           </a:p>
         </p:txBody>
@@ -3760,8 +4422,8 @@
         </p:nvSpPr>
         <p:spPr>
           <a:xfrm>
-            <a:off x="822960" y="2194560"/>
-            <a:ext cx="6400800" cy="731520"/>
+            <a:off x="822960" y="1508760"/>
+            <a:ext cx="5120640" cy="3474720"/>
           </a:xfrm>
           <a:prstGeom prst="rect">
             <a:avLst/>
@@ -3774,28 +4436,101 @@
           </a:bodyPr>
           <a:lstStyle/>
           <a:p>
-            <a:r>
-              <a:rPr sz="3400" b="1">
-                <a:solidFill>
-                  <a:srgbClr val="72256D"/>
-                </a:solidFill>
-                <a:latin typeface="Aptos"/>
-              </a:rPr>
-              <a:t>Discussion</a:t>
-            </a:r>
-          </a:p>
-        </p:txBody>
-      </p:sp>
-      <p:sp>
-        <p:nvSpPr>
-          <p:cNvPr id="7" name="TextBox 6"/>
+            <a:pPr>
+              <a:defRPr sz="1800">
+                <a:solidFill>
+                  <a:srgbClr val="201A2A"/>
+                </a:solidFill>
+                <a:latin typeface="Aptos"/>
+              </a:defRPr>
+            </a:pPr>
+            <a:r>
+              <a:t>Observed gap in the prior workflow</a:t>
+            </a:r>
+          </a:p>
+          <a:p>
+            <a:pPr>
+              <a:defRPr sz="1800">
+                <a:solidFill>
+                  <a:srgbClr val="201A2A"/>
+                </a:solidFill>
+                <a:latin typeface="Aptos"/>
+              </a:defRPr>
+            </a:pPr>
+            <a:r>
+              <a:t>Primary endpoint and cohort boundary</a:t>
+            </a:r>
+          </a:p>
+          <a:p>
+            <a:pPr>
+              <a:defRPr sz="1800">
+                <a:solidFill>
+                  <a:srgbClr val="201A2A"/>
+                </a:solidFill>
+                <a:latin typeface="Aptos"/>
+              </a:defRPr>
+            </a:pPr>
+            <a:r>
+              <a:t>Decision that the slide deck should support</a:t>
+            </a:r>
+          </a:p>
+        </p:txBody>
+      </p:sp>
+      <p:sp>
+        <p:nvSpPr>
+          <p:cNvPr id="7" name="Rounded Rectangle 6"/>
+          <p:cNvSpPr/>
+          <p:nvPr/>
+        </p:nvSpPr>
+        <p:spPr>
+          <a:xfrm>
+            <a:off x="6492240" y="1508760"/>
+            <a:ext cx="4297680" cy="2560320"/>
+          </a:xfrm>
+          <a:prstGeom prst="roundRect">
+            <a:avLst/>
+          </a:prstGeom>
+          <a:solidFill>
+            <a:srgbClr val="F7F0F6"/>
+          </a:solidFill>
+          <a:ln>
+            <a:solidFill>
+              <a:srgbClr val="AA7CA7"/>
+            </a:solidFill>
+          </a:ln>
+        </p:spPr>
+        <p:style>
+          <a:lnRef idx="1">
+            <a:schemeClr val="accent1"/>
+          </a:lnRef>
+          <a:fillRef idx="3">
+            <a:schemeClr val="accent1"/>
+          </a:fillRef>
+          <a:effectRef idx="2">
+            <a:schemeClr val="accent1"/>
+          </a:effectRef>
+          <a:fontRef idx="minor">
+            <a:schemeClr val="lt1"/>
+          </a:fontRef>
+        </p:style>
+        <p:txBody>
+          <a:bodyPr rtlCol="0" anchor="ctr"/>
+          <a:lstStyle/>
+          <a:p>
+            <a:pPr algn="ctr"/>
+          </a:p>
+        </p:txBody>
+      </p:sp>
+      <p:sp>
+        <p:nvSpPr>
+          <p:cNvPr id="8" name="TextBox 7"/>
           <p:cNvSpPr txBox="1"/>
           <p:nvPr/>
         </p:nvSpPr>
         <p:spPr>
           <a:xfrm>
-            <a:off x="841248" y="3063240"/>
-            <a:ext cx="7315200" cy="457200"/>
+            <a:off x="6720840" y="1737360"/>
+            <a:ext cx="3840480" cy="320040"/>
           </a:xfrm>
           <a:prstGeom prst="rect">
             <a:avLst/>
@@ -3809,13 +4544,3602 @@
           <a:lstStyle/>
           <a:p>
             <a:r>
-              <a:rPr sz="1800" b="0">
+              <a:rPr sz="1500" b="1">
+                <a:solidFill>
+                  <a:srgbClr val="72256D"/>
+                </a:solidFill>
+                <a:latin typeface="Aptos"/>
+              </a:rPr>
+              <a:t>Source anchor</a:t>
+            </a:r>
+          </a:p>
+        </p:txBody>
+      </p:sp>
+      <p:sp>
+        <p:nvSpPr>
+          <p:cNvPr id="9" name="TextBox 8"/>
+          <p:cNvSpPr txBox="1"/>
+          <p:nvPr/>
+        </p:nvSpPr>
+        <p:spPr>
+          <a:xfrm>
+            <a:off x="6720840" y="2194560"/>
+            <a:ext cx="3840480" cy="1645920"/>
+          </a:xfrm>
+          <a:prstGeom prst="rect">
+            <a:avLst/>
+          </a:prstGeom>
+          <a:noFill/>
+        </p:spPr>
+        <p:txBody>
+          <a:bodyPr wrap="none">
+            <a:spAutoFit/>
+          </a:bodyPr>
+          <a:lstStyle/>
+          <a:p>
+            <a:r>
+              <a:rPr sz="1200" b="0">
                 <a:solidFill>
                   <a:srgbClr val="201A2A"/>
                 </a:solidFill>
                 <a:latin typeface="Aptos"/>
               </a:rPr>
-              <a:t>Questions, next decisions, or contact information.</a:t>
+              <a:t>Paper page, repo result, notebook cell, or figure id stays attached to the slide plan.</a:t>
+            </a:r>
+          </a:p>
+        </p:txBody>
+      </p:sp>
+    </p:spTree>
+  </p:cSld>
+  <p:clrMapOvr>
+    <a:masterClrMapping/>
+  </p:clrMapOvr>
+</p:sld>
+</file>
+
+<file path=ppt/slides/slide4.xml><?xml version="1.0" encoding="utf-8"?>
+<p:sld xmlns:a="http://schemas.openxmlformats.org/drawingml/2006/main" xmlns:p="http://schemas.openxmlformats.org/presentationml/2006/main" xmlns:r="http://schemas.openxmlformats.org/officeDocument/2006/relationships">
+  <p:cSld>
+    <p:spTree>
+      <p:nvGrpSpPr>
+        <p:cNvPr id="1" name=""/>
+        <p:cNvGrpSpPr/>
+        <p:nvPr/>
+      </p:nvGrpSpPr>
+      <p:grpSpPr/>
+      <p:sp>
+        <p:nvSpPr>
+          <p:cNvPr id="2" name="Rectangle 1"/>
+          <p:cNvSpPr/>
+          <p:nvPr/>
+        </p:nvSpPr>
+        <p:spPr>
+          <a:xfrm>
+            <a:off x="0" y="0"/>
+            <a:ext cx="12191695" cy="384048"/>
+          </a:xfrm>
+          <a:prstGeom prst="rect">
+            <a:avLst/>
+          </a:prstGeom>
+          <a:solidFill>
+            <a:srgbClr val="72256D"/>
+          </a:solidFill>
+          <a:ln>
+            <a:noFill/>
+          </a:ln>
+        </p:spPr>
+        <p:style>
+          <a:lnRef idx="1">
+            <a:schemeClr val="accent1"/>
+          </a:lnRef>
+          <a:fillRef idx="3">
+            <a:schemeClr val="accent1"/>
+          </a:fillRef>
+          <a:effectRef idx="2">
+            <a:schemeClr val="accent1"/>
+          </a:effectRef>
+          <a:fontRef idx="minor">
+            <a:schemeClr val="lt1"/>
+          </a:fontRef>
+        </p:style>
+        <p:txBody>
+          <a:bodyPr rtlCol="0" anchor="ctr"/>
+          <a:lstStyle/>
+          <a:p>
+            <a:pPr algn="ctr"/>
+          </a:p>
+        </p:txBody>
+      </p:sp>
+      <p:sp>
+        <p:nvSpPr>
+          <p:cNvPr id="3" name="TextBox 2"/>
+          <p:cNvSpPr txBox="1"/>
+          <p:nvPr/>
+        </p:nvSpPr>
+        <p:spPr>
+          <a:xfrm>
+            <a:off x="411480" y="73152"/>
+            <a:ext cx="6858000" cy="228600"/>
+          </a:xfrm>
+          <a:prstGeom prst="rect">
+            <a:avLst/>
+          </a:prstGeom>
+          <a:noFill/>
+        </p:spPr>
+        <p:txBody>
+          <a:bodyPr wrap="none">
+            <a:spAutoFit/>
+          </a:bodyPr>
+          <a:lstStyle/>
+          <a:p>
+            <a:r>
+              <a:rPr sz="900" b="0">
+                <a:solidFill>
+                  <a:srgbClr val="FFFFFF"/>
+                </a:solidFill>
+                <a:latin typeface="Aptos"/>
+              </a:rPr>
+              <a:t>Method</a:t>
+            </a:r>
+          </a:p>
+        </p:txBody>
+      </p:sp>
+      <p:sp>
+        <p:nvSpPr>
+          <p:cNvPr id="4" name="TextBox 3"/>
+          <p:cNvSpPr txBox="1"/>
+          <p:nvPr/>
+        </p:nvSpPr>
+        <p:spPr>
+          <a:xfrm>
+            <a:off x="10607040" y="73152"/>
+            <a:ext cx="1097280" cy="228600"/>
+          </a:xfrm>
+          <a:prstGeom prst="rect">
+            <a:avLst/>
+          </a:prstGeom>
+          <a:noFill/>
+        </p:spPr>
+        <p:txBody>
+          <a:bodyPr wrap="none">
+            <a:spAutoFit/>
+          </a:bodyPr>
+          <a:lstStyle/>
+          <a:p>
+            <a:r>
+              <a:rPr sz="900" b="0">
+                <a:solidFill>
+                  <a:srgbClr val="FFFFFF"/>
+                </a:solidFill>
+                <a:latin typeface="Aptos"/>
+              </a:rPr>
+              <a:t>4</a:t>
+            </a:r>
+          </a:p>
+        </p:txBody>
+      </p:sp>
+      <p:sp>
+        <p:nvSpPr>
+          <p:cNvPr id="5" name="TextBox 4"/>
+          <p:cNvSpPr txBox="1"/>
+          <p:nvPr/>
+        </p:nvSpPr>
+        <p:spPr>
+          <a:xfrm>
+            <a:off x="594360" y="658368"/>
+            <a:ext cx="9875520" cy="502920"/>
+          </a:xfrm>
+          <a:prstGeom prst="rect">
+            <a:avLst/>
+          </a:prstGeom>
+          <a:noFill/>
+        </p:spPr>
+        <p:txBody>
+          <a:bodyPr wrap="none">
+            <a:spAutoFit/>
+          </a:bodyPr>
+          <a:lstStyle/>
+          <a:p>
+            <a:r>
+              <a:rPr sz="2800" b="1">
+                <a:solidFill>
+                  <a:srgbClr val="201A2A"/>
+                </a:solidFill>
+                <a:latin typeface="Aptos"/>
+              </a:rPr>
+              <a:t>Methods Overview</a:t>
+            </a:r>
+          </a:p>
+        </p:txBody>
+      </p:sp>
+      <p:sp>
+        <p:nvSpPr>
+          <p:cNvPr id="6" name="Rounded Rectangle 5"/>
+          <p:cNvSpPr/>
+          <p:nvPr/>
+        </p:nvSpPr>
+        <p:spPr>
+          <a:xfrm>
+            <a:off x="731520" y="1600200"/>
+            <a:ext cx="2331720" cy="2377440"/>
+          </a:xfrm>
+          <a:prstGeom prst="roundRect">
+            <a:avLst/>
+          </a:prstGeom>
+          <a:solidFill>
+            <a:srgbClr val="F7F0F6"/>
+          </a:solidFill>
+          <a:ln>
+            <a:solidFill>
+              <a:srgbClr val="AA7CA7"/>
+            </a:solidFill>
+          </a:ln>
+        </p:spPr>
+        <p:style>
+          <a:lnRef idx="1">
+            <a:schemeClr val="accent1"/>
+          </a:lnRef>
+          <a:fillRef idx="3">
+            <a:schemeClr val="accent1"/>
+          </a:fillRef>
+          <a:effectRef idx="2">
+            <a:schemeClr val="accent1"/>
+          </a:effectRef>
+          <a:fontRef idx="minor">
+            <a:schemeClr val="lt1"/>
+          </a:fontRef>
+        </p:style>
+        <p:txBody>
+          <a:bodyPr rtlCol="0" anchor="ctr"/>
+          <a:lstStyle/>
+          <a:p>
+            <a:pPr algn="ctr"/>
+          </a:p>
+        </p:txBody>
+      </p:sp>
+      <p:sp>
+        <p:nvSpPr>
+          <p:cNvPr id="7" name="TextBox 6"/>
+          <p:cNvSpPr txBox="1"/>
+          <p:nvPr/>
+        </p:nvSpPr>
+        <p:spPr>
+          <a:xfrm>
+            <a:off x="960120" y="1828800"/>
+            <a:ext cx="1874520" cy="320040"/>
+          </a:xfrm>
+          <a:prstGeom prst="rect">
+            <a:avLst/>
+          </a:prstGeom>
+          <a:noFill/>
+        </p:spPr>
+        <p:txBody>
+          <a:bodyPr wrap="none">
+            <a:spAutoFit/>
+          </a:bodyPr>
+          <a:lstStyle/>
+          <a:p>
+            <a:r>
+              <a:rPr sz="1500" b="1">
+                <a:solidFill>
+                  <a:srgbClr val="72256D"/>
+                </a:solidFill>
+                <a:latin typeface="Aptos"/>
+              </a:rPr>
+              <a:t>Input</a:t>
+            </a:r>
+          </a:p>
+        </p:txBody>
+      </p:sp>
+      <p:sp>
+        <p:nvSpPr>
+          <p:cNvPr id="8" name="TextBox 7"/>
+          <p:cNvSpPr txBox="1"/>
+          <p:nvPr/>
+        </p:nvSpPr>
+        <p:spPr>
+          <a:xfrm>
+            <a:off x="960120" y="2286000"/>
+            <a:ext cx="1874520" cy="1463040"/>
+          </a:xfrm>
+          <a:prstGeom prst="rect">
+            <a:avLst/>
+          </a:prstGeom>
+          <a:noFill/>
+        </p:spPr>
+        <p:txBody>
+          <a:bodyPr wrap="none">
+            <a:spAutoFit/>
+          </a:bodyPr>
+          <a:lstStyle/>
+          <a:p>
+            <a:r>
+              <a:rPr sz="1200" b="0">
+                <a:solidFill>
+                  <a:srgbClr val="201A2A"/>
+                </a:solidFill>
+                <a:latin typeface="Aptos"/>
+              </a:rPr>
+              <a:t>Editable process block with concise evidence.</a:t>
+            </a:r>
+          </a:p>
+        </p:txBody>
+      </p:sp>
+      <p:sp>
+        <p:nvSpPr>
+          <p:cNvPr id="9" name="Rounded Rectangle 8"/>
+          <p:cNvSpPr/>
+          <p:nvPr/>
+        </p:nvSpPr>
+        <p:spPr>
+          <a:xfrm>
+            <a:off x="3520439" y="1600200"/>
+            <a:ext cx="2331720" cy="2377440"/>
+          </a:xfrm>
+          <a:prstGeom prst="roundRect">
+            <a:avLst/>
+          </a:prstGeom>
+          <a:solidFill>
+            <a:srgbClr val="F7F0F6"/>
+          </a:solidFill>
+          <a:ln>
+            <a:solidFill>
+              <a:srgbClr val="AA7CA7"/>
+            </a:solidFill>
+          </a:ln>
+        </p:spPr>
+        <p:style>
+          <a:lnRef idx="1">
+            <a:schemeClr val="accent1"/>
+          </a:lnRef>
+          <a:fillRef idx="3">
+            <a:schemeClr val="accent1"/>
+          </a:fillRef>
+          <a:effectRef idx="2">
+            <a:schemeClr val="accent1"/>
+          </a:effectRef>
+          <a:fontRef idx="minor">
+            <a:schemeClr val="lt1"/>
+          </a:fontRef>
+        </p:style>
+        <p:txBody>
+          <a:bodyPr rtlCol="0" anchor="ctr"/>
+          <a:lstStyle/>
+          <a:p>
+            <a:pPr algn="ctr"/>
+          </a:p>
+        </p:txBody>
+      </p:sp>
+      <p:sp>
+        <p:nvSpPr>
+          <p:cNvPr id="10" name="TextBox 9"/>
+          <p:cNvSpPr txBox="1"/>
+          <p:nvPr/>
+        </p:nvSpPr>
+        <p:spPr>
+          <a:xfrm>
+            <a:off x="3749039" y="1828800"/>
+            <a:ext cx="1874520" cy="320040"/>
+          </a:xfrm>
+          <a:prstGeom prst="rect">
+            <a:avLst/>
+          </a:prstGeom>
+          <a:noFill/>
+        </p:spPr>
+        <p:txBody>
+          <a:bodyPr wrap="none">
+            <a:spAutoFit/>
+          </a:bodyPr>
+          <a:lstStyle/>
+          <a:p>
+            <a:r>
+              <a:rPr sz="1500" b="1">
+                <a:solidFill>
+                  <a:srgbClr val="72256D"/>
+                </a:solidFill>
+                <a:latin typeface="Aptos"/>
+              </a:rPr>
+              <a:t>Model</a:t>
+            </a:r>
+          </a:p>
+        </p:txBody>
+      </p:sp>
+      <p:sp>
+        <p:nvSpPr>
+          <p:cNvPr id="11" name="TextBox 10"/>
+          <p:cNvSpPr txBox="1"/>
+          <p:nvPr/>
+        </p:nvSpPr>
+        <p:spPr>
+          <a:xfrm>
+            <a:off x="3749039" y="2286000"/>
+            <a:ext cx="1874520" cy="1463040"/>
+          </a:xfrm>
+          <a:prstGeom prst="rect">
+            <a:avLst/>
+          </a:prstGeom>
+          <a:noFill/>
+        </p:spPr>
+        <p:txBody>
+          <a:bodyPr wrap="none">
+            <a:spAutoFit/>
+          </a:bodyPr>
+          <a:lstStyle/>
+          <a:p>
+            <a:r>
+              <a:rPr sz="1200" b="0">
+                <a:solidFill>
+                  <a:srgbClr val="201A2A"/>
+                </a:solidFill>
+                <a:latin typeface="Aptos"/>
+              </a:rPr>
+              <a:t>Editable process block with concise evidence.</a:t>
+            </a:r>
+          </a:p>
+        </p:txBody>
+      </p:sp>
+      <p:sp>
+        <p:nvSpPr>
+          <p:cNvPr id="12" name="Rounded Rectangle 11"/>
+          <p:cNvSpPr/>
+          <p:nvPr/>
+        </p:nvSpPr>
+        <p:spPr>
+          <a:xfrm>
+            <a:off x="6309359" y="1600200"/>
+            <a:ext cx="2331720" cy="2377440"/>
+          </a:xfrm>
+          <a:prstGeom prst="roundRect">
+            <a:avLst/>
+          </a:prstGeom>
+          <a:solidFill>
+            <a:srgbClr val="F7F0F6"/>
+          </a:solidFill>
+          <a:ln>
+            <a:solidFill>
+              <a:srgbClr val="AA7CA7"/>
+            </a:solidFill>
+          </a:ln>
+        </p:spPr>
+        <p:style>
+          <a:lnRef idx="1">
+            <a:schemeClr val="accent1"/>
+          </a:lnRef>
+          <a:fillRef idx="3">
+            <a:schemeClr val="accent1"/>
+          </a:fillRef>
+          <a:effectRef idx="2">
+            <a:schemeClr val="accent1"/>
+          </a:effectRef>
+          <a:fontRef idx="minor">
+            <a:schemeClr val="lt1"/>
+          </a:fontRef>
+        </p:style>
+        <p:txBody>
+          <a:bodyPr rtlCol="0" anchor="ctr"/>
+          <a:lstStyle/>
+          <a:p>
+            <a:pPr algn="ctr"/>
+          </a:p>
+        </p:txBody>
+      </p:sp>
+      <p:sp>
+        <p:nvSpPr>
+          <p:cNvPr id="13" name="TextBox 12"/>
+          <p:cNvSpPr txBox="1"/>
+          <p:nvPr/>
+        </p:nvSpPr>
+        <p:spPr>
+          <a:xfrm>
+            <a:off x="6537959" y="1828800"/>
+            <a:ext cx="1874520" cy="320040"/>
+          </a:xfrm>
+          <a:prstGeom prst="rect">
+            <a:avLst/>
+          </a:prstGeom>
+          <a:noFill/>
+        </p:spPr>
+        <p:txBody>
+          <a:bodyPr wrap="none">
+            <a:spAutoFit/>
+          </a:bodyPr>
+          <a:lstStyle/>
+          <a:p>
+            <a:r>
+              <a:rPr sz="1500" b="1">
+                <a:solidFill>
+                  <a:srgbClr val="72256D"/>
+                </a:solidFill>
+                <a:latin typeface="Aptos"/>
+              </a:rPr>
+              <a:t>Validation</a:t>
+            </a:r>
+          </a:p>
+        </p:txBody>
+      </p:sp>
+      <p:sp>
+        <p:nvSpPr>
+          <p:cNvPr id="14" name="TextBox 13"/>
+          <p:cNvSpPr txBox="1"/>
+          <p:nvPr/>
+        </p:nvSpPr>
+        <p:spPr>
+          <a:xfrm>
+            <a:off x="6537959" y="2286000"/>
+            <a:ext cx="1874520" cy="1463040"/>
+          </a:xfrm>
+          <a:prstGeom prst="rect">
+            <a:avLst/>
+          </a:prstGeom>
+          <a:noFill/>
+        </p:spPr>
+        <p:txBody>
+          <a:bodyPr wrap="none">
+            <a:spAutoFit/>
+          </a:bodyPr>
+          <a:lstStyle/>
+          <a:p>
+            <a:r>
+              <a:rPr sz="1200" b="0">
+                <a:solidFill>
+                  <a:srgbClr val="201A2A"/>
+                </a:solidFill>
+                <a:latin typeface="Aptos"/>
+              </a:rPr>
+              <a:t>Editable process block with concise evidence.</a:t>
+            </a:r>
+          </a:p>
+        </p:txBody>
+      </p:sp>
+      <p:sp>
+        <p:nvSpPr>
+          <p:cNvPr id="15" name="Rounded Rectangle 14"/>
+          <p:cNvSpPr/>
+          <p:nvPr/>
+        </p:nvSpPr>
+        <p:spPr>
+          <a:xfrm>
+            <a:off x="9098280" y="1600200"/>
+            <a:ext cx="2331720" cy="2377440"/>
+          </a:xfrm>
+          <a:prstGeom prst="roundRect">
+            <a:avLst/>
+          </a:prstGeom>
+          <a:solidFill>
+            <a:srgbClr val="F7F0F6"/>
+          </a:solidFill>
+          <a:ln>
+            <a:solidFill>
+              <a:srgbClr val="AA7CA7"/>
+            </a:solidFill>
+          </a:ln>
+        </p:spPr>
+        <p:style>
+          <a:lnRef idx="1">
+            <a:schemeClr val="accent1"/>
+          </a:lnRef>
+          <a:fillRef idx="3">
+            <a:schemeClr val="accent1"/>
+          </a:fillRef>
+          <a:effectRef idx="2">
+            <a:schemeClr val="accent1"/>
+          </a:effectRef>
+          <a:fontRef idx="minor">
+            <a:schemeClr val="lt1"/>
+          </a:fontRef>
+        </p:style>
+        <p:txBody>
+          <a:bodyPr rtlCol="0" anchor="ctr"/>
+          <a:lstStyle/>
+          <a:p>
+            <a:pPr algn="ctr"/>
+          </a:p>
+        </p:txBody>
+      </p:sp>
+      <p:sp>
+        <p:nvSpPr>
+          <p:cNvPr id="16" name="TextBox 15"/>
+          <p:cNvSpPr txBox="1"/>
+          <p:nvPr/>
+        </p:nvSpPr>
+        <p:spPr>
+          <a:xfrm>
+            <a:off x="9326880" y="1828800"/>
+            <a:ext cx="1874520" cy="320040"/>
+          </a:xfrm>
+          <a:prstGeom prst="rect">
+            <a:avLst/>
+          </a:prstGeom>
+          <a:noFill/>
+        </p:spPr>
+        <p:txBody>
+          <a:bodyPr wrap="none">
+            <a:spAutoFit/>
+          </a:bodyPr>
+          <a:lstStyle/>
+          <a:p>
+            <a:r>
+              <a:rPr sz="1500" b="1">
+                <a:solidFill>
+                  <a:srgbClr val="72256D"/>
+                </a:solidFill>
+                <a:latin typeface="Aptos"/>
+              </a:rPr>
+              <a:t>Decision</a:t>
+            </a:r>
+          </a:p>
+        </p:txBody>
+      </p:sp>
+      <p:sp>
+        <p:nvSpPr>
+          <p:cNvPr id="17" name="TextBox 16"/>
+          <p:cNvSpPr txBox="1"/>
+          <p:nvPr/>
+        </p:nvSpPr>
+        <p:spPr>
+          <a:xfrm>
+            <a:off x="9326880" y="2286000"/>
+            <a:ext cx="1874520" cy="1463040"/>
+          </a:xfrm>
+          <a:prstGeom prst="rect">
+            <a:avLst/>
+          </a:prstGeom>
+          <a:noFill/>
+        </p:spPr>
+        <p:txBody>
+          <a:bodyPr wrap="none">
+            <a:spAutoFit/>
+          </a:bodyPr>
+          <a:lstStyle/>
+          <a:p>
+            <a:r>
+              <a:rPr sz="1200" b="0">
+                <a:solidFill>
+                  <a:srgbClr val="201A2A"/>
+                </a:solidFill>
+                <a:latin typeface="Aptos"/>
+              </a:rPr>
+              <a:t>Editable process block with concise evidence.</a:t>
+            </a:r>
+          </a:p>
+        </p:txBody>
+      </p:sp>
+      <p:sp>
+        <p:nvSpPr>
+          <p:cNvPr id="18" name="TextBox 17"/>
+          <p:cNvSpPr txBox="1"/>
+          <p:nvPr/>
+        </p:nvSpPr>
+        <p:spPr>
+          <a:xfrm>
+            <a:off x="822960" y="4754880"/>
+            <a:ext cx="10241280" cy="365760"/>
+          </a:xfrm>
+          <a:prstGeom prst="rect">
+            <a:avLst/>
+          </a:prstGeom>
+          <a:noFill/>
+        </p:spPr>
+        <p:txBody>
+          <a:bodyPr wrap="none">
+            <a:spAutoFit/>
+          </a:bodyPr>
+          <a:lstStyle/>
+          <a:p>
+            <a:r>
+              <a:rPr sz="1400" b="0">
+                <a:solidFill>
+                  <a:srgbClr val="201A2A"/>
+                </a:solidFill>
+                <a:latin typeface="Aptos"/>
+              </a:rPr>
+              <a:t>Use this layout for pipelines, study flow, or experiment stages.</a:t>
+            </a:r>
+          </a:p>
+        </p:txBody>
+      </p:sp>
+    </p:spTree>
+  </p:cSld>
+  <p:clrMapOvr>
+    <a:masterClrMapping/>
+  </p:clrMapOvr>
+</p:sld>
+</file>
+
+<file path=ppt/slides/slide5.xml><?xml version="1.0" encoding="utf-8"?>
+<p:sld xmlns:a="http://schemas.openxmlformats.org/drawingml/2006/main" xmlns:p="http://schemas.openxmlformats.org/presentationml/2006/main" xmlns:r="http://schemas.openxmlformats.org/officeDocument/2006/relationships">
+  <p:cSld>
+    <p:spTree>
+      <p:nvGrpSpPr>
+        <p:cNvPr id="1" name=""/>
+        <p:cNvGrpSpPr/>
+        <p:nvPr/>
+      </p:nvGrpSpPr>
+      <p:grpSpPr/>
+      <p:sp>
+        <p:nvSpPr>
+          <p:cNvPr id="2" name="Rectangle 1"/>
+          <p:cNvSpPr/>
+          <p:nvPr/>
+        </p:nvSpPr>
+        <p:spPr>
+          <a:xfrm>
+            <a:off x="0" y="0"/>
+            <a:ext cx="12191695" cy="384048"/>
+          </a:xfrm>
+          <a:prstGeom prst="rect">
+            <a:avLst/>
+          </a:prstGeom>
+          <a:solidFill>
+            <a:srgbClr val="72256D"/>
+          </a:solidFill>
+          <a:ln>
+            <a:noFill/>
+          </a:ln>
+        </p:spPr>
+        <p:style>
+          <a:lnRef idx="1">
+            <a:schemeClr val="accent1"/>
+          </a:lnRef>
+          <a:fillRef idx="3">
+            <a:schemeClr val="accent1"/>
+          </a:fillRef>
+          <a:effectRef idx="2">
+            <a:schemeClr val="accent1"/>
+          </a:effectRef>
+          <a:fontRef idx="minor">
+            <a:schemeClr val="lt1"/>
+          </a:fontRef>
+        </p:style>
+        <p:txBody>
+          <a:bodyPr rtlCol="0" anchor="ctr"/>
+          <a:lstStyle/>
+          <a:p>
+            <a:pPr algn="ctr"/>
+          </a:p>
+        </p:txBody>
+      </p:sp>
+      <p:sp>
+        <p:nvSpPr>
+          <p:cNvPr id="3" name="TextBox 2"/>
+          <p:cNvSpPr txBox="1"/>
+          <p:nvPr/>
+        </p:nvSpPr>
+        <p:spPr>
+          <a:xfrm>
+            <a:off x="411480" y="73152"/>
+            <a:ext cx="6858000" cy="228600"/>
+          </a:xfrm>
+          <a:prstGeom prst="rect">
+            <a:avLst/>
+          </a:prstGeom>
+          <a:noFill/>
+        </p:spPr>
+        <p:txBody>
+          <a:bodyPr wrap="none">
+            <a:spAutoFit/>
+          </a:bodyPr>
+          <a:lstStyle/>
+          <a:p>
+            <a:r>
+              <a:rPr sz="900" b="0">
+                <a:solidFill>
+                  <a:srgbClr val="FFFFFF"/>
+                </a:solidFill>
+                <a:latin typeface="Aptos"/>
+              </a:rPr>
+              <a:t>Method</a:t>
+            </a:r>
+          </a:p>
+        </p:txBody>
+      </p:sp>
+      <p:sp>
+        <p:nvSpPr>
+          <p:cNvPr id="4" name="TextBox 3"/>
+          <p:cNvSpPr txBox="1"/>
+          <p:nvPr/>
+        </p:nvSpPr>
+        <p:spPr>
+          <a:xfrm>
+            <a:off x="10607040" y="73152"/>
+            <a:ext cx="1097280" cy="228600"/>
+          </a:xfrm>
+          <a:prstGeom prst="rect">
+            <a:avLst/>
+          </a:prstGeom>
+          <a:noFill/>
+        </p:spPr>
+        <p:txBody>
+          <a:bodyPr wrap="none">
+            <a:spAutoFit/>
+          </a:bodyPr>
+          <a:lstStyle/>
+          <a:p>
+            <a:r>
+              <a:rPr sz="900" b="0">
+                <a:solidFill>
+                  <a:srgbClr val="FFFFFF"/>
+                </a:solidFill>
+                <a:latin typeface="Aptos"/>
+              </a:rPr>
+              <a:t>5</a:t>
+            </a:r>
+          </a:p>
+        </p:txBody>
+      </p:sp>
+      <p:sp>
+        <p:nvSpPr>
+          <p:cNvPr id="5" name="TextBox 4"/>
+          <p:cNvSpPr txBox="1"/>
+          <p:nvPr/>
+        </p:nvSpPr>
+        <p:spPr>
+          <a:xfrm>
+            <a:off x="594360" y="658368"/>
+            <a:ext cx="9875520" cy="502920"/>
+          </a:xfrm>
+          <a:prstGeom prst="rect">
+            <a:avLst/>
+          </a:prstGeom>
+          <a:noFill/>
+        </p:spPr>
+        <p:txBody>
+          <a:bodyPr wrap="none">
+            <a:spAutoFit/>
+          </a:bodyPr>
+          <a:lstStyle/>
+          <a:p>
+            <a:r>
+              <a:rPr sz="2800" b="1">
+                <a:solidFill>
+                  <a:srgbClr val="201A2A"/>
+                </a:solidFill>
+                <a:latin typeface="Aptos"/>
+              </a:rPr>
+              <a:t>Equation or Model</a:t>
+            </a:r>
+          </a:p>
+        </p:txBody>
+      </p:sp>
+      <p:sp>
+        <p:nvSpPr>
+          <p:cNvPr id="6" name="TextBox 5"/>
+          <p:cNvSpPr txBox="1"/>
+          <p:nvPr/>
+        </p:nvSpPr>
+        <p:spPr>
+          <a:xfrm>
+            <a:off x="914400" y="1828800"/>
+            <a:ext cx="4754880" cy="731520"/>
+          </a:xfrm>
+          <a:prstGeom prst="rect">
+            <a:avLst/>
+          </a:prstGeom>
+          <a:noFill/>
+        </p:spPr>
+        <p:txBody>
+          <a:bodyPr wrap="none">
+            <a:spAutoFit/>
+          </a:bodyPr>
+          <a:lstStyle/>
+          <a:p>
+            <a:r>
+              <a:rPr sz="2600" b="1">
+                <a:solidFill>
+                  <a:srgbClr val="72256D"/>
+                </a:solidFill>
+                <a:latin typeface="Aptos"/>
+              </a:rPr>
+              <a:t>y = f(x; theta) + epsilon</a:t>
+            </a:r>
+          </a:p>
+        </p:txBody>
+      </p:sp>
+      <p:sp>
+        <p:nvSpPr>
+          <p:cNvPr id="7" name="TextBox 6"/>
+          <p:cNvSpPr txBox="1"/>
+          <p:nvPr/>
+        </p:nvSpPr>
+        <p:spPr>
+          <a:xfrm>
+            <a:off x="6400800" y="1463040"/>
+            <a:ext cx="4389120" cy="3108960"/>
+          </a:xfrm>
+          <a:prstGeom prst="rect">
+            <a:avLst/>
+          </a:prstGeom>
+          <a:noFill/>
+        </p:spPr>
+        <p:txBody>
+          <a:bodyPr wrap="none">
+            <a:spAutoFit/>
+          </a:bodyPr>
+          <a:lstStyle/>
+          <a:p>
+            <a:pPr>
+              <a:defRPr sz="1600">
+                <a:solidFill>
+                  <a:srgbClr val="201A2A"/>
+                </a:solidFill>
+                <a:latin typeface="Aptos"/>
+              </a:defRPr>
+            </a:pPr>
+            <a:r>
+              <a:t>Keep equations as text when possible</a:t>
+            </a:r>
+          </a:p>
+          <a:p>
+            <a:pPr>
+              <a:defRPr sz="1600">
+                <a:solidFill>
+                  <a:srgbClr val="201A2A"/>
+                </a:solidFill>
+                <a:latin typeface="Aptos"/>
+              </a:defRPr>
+            </a:pPr>
+            <a:r>
+              <a:t>Preserve notation from the source</a:t>
+            </a:r>
+          </a:p>
+          <a:p>
+            <a:pPr>
+              <a:defRPr sz="1600">
+                <a:solidFill>
+                  <a:srgbClr val="201A2A"/>
+                </a:solidFill>
+                <a:latin typeface="Aptos"/>
+              </a:defRPr>
+            </a:pPr>
+            <a:r>
+              <a:t>Explain only the terms needed for the audience</a:t>
+            </a:r>
+          </a:p>
+        </p:txBody>
+      </p:sp>
+    </p:spTree>
+  </p:cSld>
+  <p:clrMapOvr>
+    <a:masterClrMapping/>
+  </p:clrMapOvr>
+</p:sld>
+</file>
+
+<file path=ppt/slides/slide6.xml><?xml version="1.0" encoding="utf-8"?>
+<p:sld xmlns:a="http://schemas.openxmlformats.org/drawingml/2006/main" xmlns:p="http://schemas.openxmlformats.org/presentationml/2006/main" xmlns:r="http://schemas.openxmlformats.org/officeDocument/2006/relationships">
+  <p:cSld>
+    <p:spTree>
+      <p:nvGrpSpPr>
+        <p:cNvPr id="1" name=""/>
+        <p:cNvGrpSpPr/>
+        <p:nvPr/>
+      </p:nvGrpSpPr>
+      <p:grpSpPr/>
+      <p:sp>
+        <p:nvSpPr>
+          <p:cNvPr id="2" name="Rectangle 1"/>
+          <p:cNvSpPr/>
+          <p:nvPr/>
+        </p:nvSpPr>
+        <p:spPr>
+          <a:xfrm>
+            <a:off x="0" y="0"/>
+            <a:ext cx="12191695" cy="384048"/>
+          </a:xfrm>
+          <a:prstGeom prst="rect">
+            <a:avLst/>
+          </a:prstGeom>
+          <a:solidFill>
+            <a:srgbClr val="72256D"/>
+          </a:solidFill>
+          <a:ln>
+            <a:noFill/>
+          </a:ln>
+        </p:spPr>
+        <p:style>
+          <a:lnRef idx="1">
+            <a:schemeClr val="accent1"/>
+          </a:lnRef>
+          <a:fillRef idx="3">
+            <a:schemeClr val="accent1"/>
+          </a:fillRef>
+          <a:effectRef idx="2">
+            <a:schemeClr val="accent1"/>
+          </a:effectRef>
+          <a:fontRef idx="minor">
+            <a:schemeClr val="lt1"/>
+          </a:fontRef>
+        </p:style>
+        <p:txBody>
+          <a:bodyPr rtlCol="0" anchor="ctr"/>
+          <a:lstStyle/>
+          <a:p>
+            <a:pPr algn="ctr"/>
+          </a:p>
+        </p:txBody>
+      </p:sp>
+      <p:sp>
+        <p:nvSpPr>
+          <p:cNvPr id="3" name="TextBox 2"/>
+          <p:cNvSpPr txBox="1"/>
+          <p:nvPr/>
+        </p:nvSpPr>
+        <p:spPr>
+          <a:xfrm>
+            <a:off x="411480" y="73152"/>
+            <a:ext cx="6858000" cy="228600"/>
+          </a:xfrm>
+          <a:prstGeom prst="rect">
+            <a:avLst/>
+          </a:prstGeom>
+          <a:noFill/>
+        </p:spPr>
+        <p:txBody>
+          <a:bodyPr wrap="none">
+            <a:spAutoFit/>
+          </a:bodyPr>
+          <a:lstStyle/>
+          <a:p>
+            <a:r>
+              <a:rPr sz="900" b="0">
+                <a:solidFill>
+                  <a:srgbClr val="FFFFFF"/>
+                </a:solidFill>
+                <a:latin typeface="Aptos"/>
+              </a:rPr>
+              <a:t>Evidence</a:t>
+            </a:r>
+          </a:p>
+        </p:txBody>
+      </p:sp>
+      <p:sp>
+        <p:nvSpPr>
+          <p:cNvPr id="4" name="TextBox 3"/>
+          <p:cNvSpPr txBox="1"/>
+          <p:nvPr/>
+        </p:nvSpPr>
+        <p:spPr>
+          <a:xfrm>
+            <a:off x="10607040" y="73152"/>
+            <a:ext cx="1097280" cy="228600"/>
+          </a:xfrm>
+          <a:prstGeom prst="rect">
+            <a:avLst/>
+          </a:prstGeom>
+          <a:noFill/>
+        </p:spPr>
+        <p:txBody>
+          <a:bodyPr wrap="none">
+            <a:spAutoFit/>
+          </a:bodyPr>
+          <a:lstStyle/>
+          <a:p>
+            <a:r>
+              <a:rPr sz="900" b="0">
+                <a:solidFill>
+                  <a:srgbClr val="FFFFFF"/>
+                </a:solidFill>
+                <a:latin typeface="Aptos"/>
+              </a:rPr>
+              <a:t>6</a:t>
+            </a:r>
+          </a:p>
+        </p:txBody>
+      </p:sp>
+      <p:sp>
+        <p:nvSpPr>
+          <p:cNvPr id="5" name="TextBox 4"/>
+          <p:cNvSpPr txBox="1"/>
+          <p:nvPr/>
+        </p:nvSpPr>
+        <p:spPr>
+          <a:xfrm>
+            <a:off x="594360" y="658368"/>
+            <a:ext cx="9875520" cy="502920"/>
+          </a:xfrm>
+          <a:prstGeom prst="rect">
+            <a:avLst/>
+          </a:prstGeom>
+          <a:noFill/>
+        </p:spPr>
+        <p:txBody>
+          <a:bodyPr wrap="none">
+            <a:spAutoFit/>
+          </a:bodyPr>
+          <a:lstStyle/>
+          <a:p>
+            <a:r>
+              <a:rPr sz="2800" b="1">
+                <a:solidFill>
+                  <a:srgbClr val="201A2A"/>
+                </a:solidFill>
+                <a:latin typeface="Aptos"/>
+              </a:rPr>
+              <a:t>Results Figure</a:t>
+            </a:r>
+          </a:p>
+        </p:txBody>
+      </p:sp>
+      <p:sp>
+        <p:nvSpPr>
+          <p:cNvPr id="6" name="Rectangle 5"/>
+          <p:cNvSpPr/>
+          <p:nvPr/>
+        </p:nvSpPr>
+        <p:spPr>
+          <a:xfrm>
+            <a:off x="822960" y="1417320"/>
+            <a:ext cx="5486400" cy="3383280"/>
+          </a:xfrm>
+          <a:prstGeom prst="rect">
+            <a:avLst/>
+          </a:prstGeom>
+          <a:solidFill>
+            <a:srgbClr val="FFFFFF"/>
+          </a:solidFill>
+          <a:ln>
+            <a:solidFill>
+              <a:srgbClr val="AA7CA7"/>
+            </a:solidFill>
+          </a:ln>
+        </p:spPr>
+        <p:style>
+          <a:lnRef idx="1">
+            <a:schemeClr val="accent1"/>
+          </a:lnRef>
+          <a:fillRef idx="3">
+            <a:schemeClr val="accent1"/>
+          </a:fillRef>
+          <a:effectRef idx="2">
+            <a:schemeClr val="accent1"/>
+          </a:effectRef>
+          <a:fontRef idx="minor">
+            <a:schemeClr val="lt1"/>
+          </a:fontRef>
+        </p:style>
+        <p:txBody>
+          <a:bodyPr rtlCol="0" anchor="ctr"/>
+          <a:lstStyle/>
+          <a:p>
+            <a:pPr algn="ctr"/>
+          </a:p>
+        </p:txBody>
+      </p:sp>
+      <p:sp>
+        <p:nvSpPr>
+          <p:cNvPr id="7" name="Rectangle 6"/>
+          <p:cNvSpPr/>
+          <p:nvPr/>
+        </p:nvSpPr>
+        <p:spPr>
+          <a:xfrm>
+            <a:off x="1280160" y="3291839"/>
+            <a:ext cx="502920" cy="1097280"/>
+          </a:xfrm>
+          <a:prstGeom prst="rect">
+            <a:avLst/>
+          </a:prstGeom>
+          <a:solidFill>
+            <a:srgbClr val="D4AF37"/>
+          </a:solidFill>
+          <a:ln>
+            <a:noFill/>
+          </a:ln>
+        </p:spPr>
+        <p:style>
+          <a:lnRef idx="1">
+            <a:schemeClr val="accent1"/>
+          </a:lnRef>
+          <a:fillRef idx="3">
+            <a:schemeClr val="accent1"/>
+          </a:fillRef>
+          <a:effectRef idx="2">
+            <a:schemeClr val="accent1"/>
+          </a:effectRef>
+          <a:fontRef idx="minor">
+            <a:schemeClr val="lt1"/>
+          </a:fontRef>
+        </p:style>
+        <p:txBody>
+          <a:bodyPr rtlCol="0" anchor="ctr"/>
+          <a:lstStyle/>
+          <a:p>
+            <a:pPr algn="ctr"/>
+          </a:p>
+        </p:txBody>
+      </p:sp>
+      <p:sp>
+        <p:nvSpPr>
+          <p:cNvPr id="8" name="Rectangle 7"/>
+          <p:cNvSpPr/>
+          <p:nvPr/>
+        </p:nvSpPr>
+        <p:spPr>
+          <a:xfrm>
+            <a:off x="2377439" y="2468879"/>
+            <a:ext cx="502920" cy="1920240"/>
+          </a:xfrm>
+          <a:prstGeom prst="rect">
+            <a:avLst/>
+          </a:prstGeom>
+          <a:solidFill>
+            <a:srgbClr val="72256D"/>
+          </a:solidFill>
+          <a:ln>
+            <a:noFill/>
+          </a:ln>
+        </p:spPr>
+        <p:style>
+          <a:lnRef idx="1">
+            <a:schemeClr val="accent1"/>
+          </a:lnRef>
+          <a:fillRef idx="3">
+            <a:schemeClr val="accent1"/>
+          </a:fillRef>
+          <a:effectRef idx="2">
+            <a:schemeClr val="accent1"/>
+          </a:effectRef>
+          <a:fontRef idx="minor">
+            <a:schemeClr val="lt1"/>
+          </a:fontRef>
+        </p:style>
+        <p:txBody>
+          <a:bodyPr rtlCol="0" anchor="ctr"/>
+          <a:lstStyle/>
+          <a:p>
+            <a:pPr algn="ctr"/>
+          </a:p>
+        </p:txBody>
+      </p:sp>
+      <p:sp>
+        <p:nvSpPr>
+          <p:cNvPr id="9" name="Rectangle 8"/>
+          <p:cNvSpPr/>
+          <p:nvPr/>
+        </p:nvSpPr>
+        <p:spPr>
+          <a:xfrm>
+            <a:off x="3474720" y="2834639"/>
+            <a:ext cx="502920" cy="1554480"/>
+          </a:xfrm>
+          <a:prstGeom prst="rect">
+            <a:avLst/>
+          </a:prstGeom>
+          <a:solidFill>
+            <a:srgbClr val="D4AF37"/>
+          </a:solidFill>
+          <a:ln>
+            <a:noFill/>
+          </a:ln>
+        </p:spPr>
+        <p:style>
+          <a:lnRef idx="1">
+            <a:schemeClr val="accent1"/>
+          </a:lnRef>
+          <a:fillRef idx="3">
+            <a:schemeClr val="accent1"/>
+          </a:fillRef>
+          <a:effectRef idx="2">
+            <a:schemeClr val="accent1"/>
+          </a:effectRef>
+          <a:fontRef idx="minor">
+            <a:schemeClr val="lt1"/>
+          </a:fontRef>
+        </p:style>
+        <p:txBody>
+          <a:bodyPr rtlCol="0" anchor="ctr"/>
+          <a:lstStyle/>
+          <a:p>
+            <a:pPr algn="ctr"/>
+          </a:p>
+        </p:txBody>
+      </p:sp>
+      <p:sp>
+        <p:nvSpPr>
+          <p:cNvPr id="10" name="Rectangle 9"/>
+          <p:cNvSpPr/>
+          <p:nvPr/>
+        </p:nvSpPr>
+        <p:spPr>
+          <a:xfrm>
+            <a:off x="4572000" y="1828800"/>
+            <a:ext cx="502920" cy="2560320"/>
+          </a:xfrm>
+          <a:prstGeom prst="rect">
+            <a:avLst/>
+          </a:prstGeom>
+          <a:solidFill>
+            <a:srgbClr val="72256D"/>
+          </a:solidFill>
+          <a:ln>
+            <a:noFill/>
+          </a:ln>
+        </p:spPr>
+        <p:style>
+          <a:lnRef idx="1">
+            <a:schemeClr val="accent1"/>
+          </a:lnRef>
+          <a:fillRef idx="3">
+            <a:schemeClr val="accent1"/>
+          </a:fillRef>
+          <a:effectRef idx="2">
+            <a:schemeClr val="accent1"/>
+          </a:effectRef>
+          <a:fontRef idx="minor">
+            <a:schemeClr val="lt1"/>
+          </a:fontRef>
+        </p:style>
+        <p:txBody>
+          <a:bodyPr rtlCol="0" anchor="ctr"/>
+          <a:lstStyle/>
+          <a:p>
+            <a:pPr algn="ctr"/>
+          </a:p>
+        </p:txBody>
+      </p:sp>
+      <p:sp>
+        <p:nvSpPr>
+          <p:cNvPr id="11" name="Rounded Rectangle 10"/>
+          <p:cNvSpPr/>
+          <p:nvPr/>
+        </p:nvSpPr>
+        <p:spPr>
+          <a:xfrm>
+            <a:off x="6766560" y="1508760"/>
+            <a:ext cx="3840480" cy="2834640"/>
+          </a:xfrm>
+          <a:prstGeom prst="roundRect">
+            <a:avLst/>
+          </a:prstGeom>
+          <a:solidFill>
+            <a:srgbClr val="F7F0F6"/>
+          </a:solidFill>
+          <a:ln>
+            <a:solidFill>
+              <a:srgbClr val="AA7CA7"/>
+            </a:solidFill>
+          </a:ln>
+        </p:spPr>
+        <p:style>
+          <a:lnRef idx="1">
+            <a:schemeClr val="accent1"/>
+          </a:lnRef>
+          <a:fillRef idx="3">
+            <a:schemeClr val="accent1"/>
+          </a:fillRef>
+          <a:effectRef idx="2">
+            <a:schemeClr val="accent1"/>
+          </a:effectRef>
+          <a:fontRef idx="minor">
+            <a:schemeClr val="lt1"/>
+          </a:fontRef>
+        </p:style>
+        <p:txBody>
+          <a:bodyPr rtlCol="0" anchor="ctr"/>
+          <a:lstStyle/>
+          <a:p>
+            <a:pPr algn="ctr"/>
+          </a:p>
+        </p:txBody>
+      </p:sp>
+      <p:sp>
+        <p:nvSpPr>
+          <p:cNvPr id="12" name="TextBox 11"/>
+          <p:cNvSpPr txBox="1"/>
+          <p:nvPr/>
+        </p:nvSpPr>
+        <p:spPr>
+          <a:xfrm>
+            <a:off x="6995160" y="1737360"/>
+            <a:ext cx="3383280" cy="320040"/>
+          </a:xfrm>
+          <a:prstGeom prst="rect">
+            <a:avLst/>
+          </a:prstGeom>
+          <a:noFill/>
+        </p:spPr>
+        <p:txBody>
+          <a:bodyPr wrap="none">
+            <a:spAutoFit/>
+          </a:bodyPr>
+          <a:lstStyle/>
+          <a:p>
+            <a:r>
+              <a:rPr sz="1500" b="1">
+                <a:solidFill>
+                  <a:srgbClr val="72256D"/>
+                </a:solidFill>
+                <a:latin typeface="Aptos"/>
+              </a:rPr>
+              <a:t>Interpretation</a:t>
+            </a:r>
+          </a:p>
+        </p:txBody>
+      </p:sp>
+      <p:sp>
+        <p:nvSpPr>
+          <p:cNvPr id="13" name="TextBox 12"/>
+          <p:cNvSpPr txBox="1"/>
+          <p:nvPr/>
+        </p:nvSpPr>
+        <p:spPr>
+          <a:xfrm>
+            <a:off x="6995160" y="2194560"/>
+            <a:ext cx="3383280" cy="1920240"/>
+          </a:xfrm>
+          <a:prstGeom prst="rect">
+            <a:avLst/>
+          </a:prstGeom>
+          <a:noFill/>
+        </p:spPr>
+        <p:txBody>
+          <a:bodyPr wrap="none">
+            <a:spAutoFit/>
+          </a:bodyPr>
+          <a:lstStyle/>
+          <a:p>
+            <a:r>
+              <a:rPr sz="1200" b="0">
+                <a:solidFill>
+                  <a:srgbClr val="201A2A"/>
+                </a:solidFill>
+                <a:latin typeface="Aptos"/>
+              </a:rPr>
+              <a:t>State what changed, how large it was, and what remains uncertain.</a:t>
+            </a:r>
+          </a:p>
+        </p:txBody>
+      </p:sp>
+    </p:spTree>
+  </p:cSld>
+  <p:clrMapOvr>
+    <a:masterClrMapping/>
+  </p:clrMapOvr>
+</p:sld>
+</file>
+
+<file path=ppt/slides/slide7.xml><?xml version="1.0" encoding="utf-8"?>
+<p:sld xmlns:a="http://schemas.openxmlformats.org/drawingml/2006/main" xmlns:p="http://schemas.openxmlformats.org/presentationml/2006/main" xmlns:r="http://schemas.openxmlformats.org/officeDocument/2006/relationships">
+  <p:cSld>
+    <p:spTree>
+      <p:nvGrpSpPr>
+        <p:cNvPr id="1" name=""/>
+        <p:cNvGrpSpPr/>
+        <p:nvPr/>
+      </p:nvGrpSpPr>
+      <p:grpSpPr/>
+      <p:sp>
+        <p:nvSpPr>
+          <p:cNvPr id="2" name="Rectangle 1"/>
+          <p:cNvSpPr/>
+          <p:nvPr/>
+        </p:nvSpPr>
+        <p:spPr>
+          <a:xfrm>
+            <a:off x="0" y="0"/>
+            <a:ext cx="12191695" cy="384048"/>
+          </a:xfrm>
+          <a:prstGeom prst="rect">
+            <a:avLst/>
+          </a:prstGeom>
+          <a:solidFill>
+            <a:srgbClr val="72256D"/>
+          </a:solidFill>
+          <a:ln>
+            <a:noFill/>
+          </a:ln>
+        </p:spPr>
+        <p:style>
+          <a:lnRef idx="1">
+            <a:schemeClr val="accent1"/>
+          </a:lnRef>
+          <a:fillRef idx="3">
+            <a:schemeClr val="accent1"/>
+          </a:fillRef>
+          <a:effectRef idx="2">
+            <a:schemeClr val="accent1"/>
+          </a:effectRef>
+          <a:fontRef idx="minor">
+            <a:schemeClr val="lt1"/>
+          </a:fontRef>
+        </p:style>
+        <p:txBody>
+          <a:bodyPr rtlCol="0" anchor="ctr"/>
+          <a:lstStyle/>
+          <a:p>
+            <a:pPr algn="ctr"/>
+          </a:p>
+        </p:txBody>
+      </p:sp>
+      <p:sp>
+        <p:nvSpPr>
+          <p:cNvPr id="3" name="TextBox 2"/>
+          <p:cNvSpPr txBox="1"/>
+          <p:nvPr/>
+        </p:nvSpPr>
+        <p:spPr>
+          <a:xfrm>
+            <a:off x="411480" y="73152"/>
+            <a:ext cx="6858000" cy="228600"/>
+          </a:xfrm>
+          <a:prstGeom prst="rect">
+            <a:avLst/>
+          </a:prstGeom>
+          <a:noFill/>
+        </p:spPr>
+        <p:txBody>
+          <a:bodyPr wrap="none">
+            <a:spAutoFit/>
+          </a:bodyPr>
+          <a:lstStyle/>
+          <a:p>
+            <a:r>
+              <a:rPr sz="900" b="0">
+                <a:solidFill>
+                  <a:srgbClr val="FFFFFF"/>
+                </a:solidFill>
+                <a:latin typeface="Aptos"/>
+              </a:rPr>
+              <a:t>Evidence</a:t>
+            </a:r>
+          </a:p>
+        </p:txBody>
+      </p:sp>
+      <p:sp>
+        <p:nvSpPr>
+          <p:cNvPr id="4" name="TextBox 3"/>
+          <p:cNvSpPr txBox="1"/>
+          <p:nvPr/>
+        </p:nvSpPr>
+        <p:spPr>
+          <a:xfrm>
+            <a:off x="10607040" y="73152"/>
+            <a:ext cx="1097280" cy="228600"/>
+          </a:xfrm>
+          <a:prstGeom prst="rect">
+            <a:avLst/>
+          </a:prstGeom>
+          <a:noFill/>
+        </p:spPr>
+        <p:txBody>
+          <a:bodyPr wrap="none">
+            <a:spAutoFit/>
+          </a:bodyPr>
+          <a:lstStyle/>
+          <a:p>
+            <a:r>
+              <a:rPr sz="900" b="0">
+                <a:solidFill>
+                  <a:srgbClr val="FFFFFF"/>
+                </a:solidFill>
+                <a:latin typeface="Aptos"/>
+              </a:rPr>
+              <a:t>7</a:t>
+            </a:r>
+          </a:p>
+        </p:txBody>
+      </p:sp>
+      <p:sp>
+        <p:nvSpPr>
+          <p:cNvPr id="5" name="TextBox 4"/>
+          <p:cNvSpPr txBox="1"/>
+          <p:nvPr/>
+        </p:nvSpPr>
+        <p:spPr>
+          <a:xfrm>
+            <a:off x="594360" y="658368"/>
+            <a:ext cx="9875520" cy="502920"/>
+          </a:xfrm>
+          <a:prstGeom prst="rect">
+            <a:avLst/>
+          </a:prstGeom>
+          <a:noFill/>
+        </p:spPr>
+        <p:txBody>
+          <a:bodyPr wrap="none">
+            <a:spAutoFit/>
+          </a:bodyPr>
+          <a:lstStyle/>
+          <a:p>
+            <a:r>
+              <a:rPr sz="2800" b="1">
+                <a:solidFill>
+                  <a:srgbClr val="201A2A"/>
+                </a:solidFill>
+                <a:latin typeface="Aptos"/>
+              </a:rPr>
+              <a:t>Comparison</a:t>
+            </a:r>
+          </a:p>
+        </p:txBody>
+      </p:sp>
+      <p:sp>
+        <p:nvSpPr>
+          <p:cNvPr id="6" name="Rounded Rectangle 5"/>
+          <p:cNvSpPr/>
+          <p:nvPr/>
+        </p:nvSpPr>
+        <p:spPr>
+          <a:xfrm>
+            <a:off x="822960" y="1508760"/>
+            <a:ext cx="4663440" cy="3200400"/>
+          </a:xfrm>
+          <a:prstGeom prst="roundRect">
+            <a:avLst/>
+          </a:prstGeom>
+          <a:solidFill>
+            <a:srgbClr val="F7F0F6"/>
+          </a:solidFill>
+          <a:ln>
+            <a:solidFill>
+              <a:srgbClr val="AA7CA7"/>
+            </a:solidFill>
+          </a:ln>
+        </p:spPr>
+        <p:style>
+          <a:lnRef idx="1">
+            <a:schemeClr val="accent1"/>
+          </a:lnRef>
+          <a:fillRef idx="3">
+            <a:schemeClr val="accent1"/>
+          </a:fillRef>
+          <a:effectRef idx="2">
+            <a:schemeClr val="accent1"/>
+          </a:effectRef>
+          <a:fontRef idx="minor">
+            <a:schemeClr val="lt1"/>
+          </a:fontRef>
+        </p:style>
+        <p:txBody>
+          <a:bodyPr rtlCol="0" anchor="ctr"/>
+          <a:lstStyle/>
+          <a:p>
+            <a:pPr algn="ctr"/>
+          </a:p>
+        </p:txBody>
+      </p:sp>
+      <p:sp>
+        <p:nvSpPr>
+          <p:cNvPr id="7" name="TextBox 6"/>
+          <p:cNvSpPr txBox="1"/>
+          <p:nvPr/>
+        </p:nvSpPr>
+        <p:spPr>
+          <a:xfrm>
+            <a:off x="1051560" y="1737360"/>
+            <a:ext cx="4206240" cy="320040"/>
+          </a:xfrm>
+          <a:prstGeom prst="rect">
+            <a:avLst/>
+          </a:prstGeom>
+          <a:noFill/>
+        </p:spPr>
+        <p:txBody>
+          <a:bodyPr wrap="none">
+            <a:spAutoFit/>
+          </a:bodyPr>
+          <a:lstStyle/>
+          <a:p>
+            <a:r>
+              <a:rPr sz="1500" b="1">
+                <a:solidFill>
+                  <a:srgbClr val="72256D"/>
+                </a:solidFill>
+                <a:latin typeface="Aptos"/>
+              </a:rPr>
+              <a:t>Baseline</a:t>
+            </a:r>
+          </a:p>
+        </p:txBody>
+      </p:sp>
+      <p:sp>
+        <p:nvSpPr>
+          <p:cNvPr id="8" name="TextBox 7"/>
+          <p:cNvSpPr txBox="1"/>
+          <p:nvPr/>
+        </p:nvSpPr>
+        <p:spPr>
+          <a:xfrm>
+            <a:off x="1051560" y="2194560"/>
+            <a:ext cx="4206240" cy="2286000"/>
+          </a:xfrm>
+          <a:prstGeom prst="rect">
+            <a:avLst/>
+          </a:prstGeom>
+          <a:noFill/>
+        </p:spPr>
+        <p:txBody>
+          <a:bodyPr wrap="none">
+            <a:spAutoFit/>
+          </a:bodyPr>
+          <a:lstStyle/>
+          <a:p>
+            <a:r>
+              <a:rPr sz="1200" b="0">
+                <a:solidFill>
+                  <a:srgbClr val="201A2A"/>
+                </a:solidFill>
+                <a:latin typeface="Aptos"/>
+              </a:rPr>
+              <a:t>Strengths, limits, and key metric.</a:t>
+            </a:r>
+          </a:p>
+        </p:txBody>
+      </p:sp>
+      <p:sp>
+        <p:nvSpPr>
+          <p:cNvPr id="9" name="Rounded Rectangle 8"/>
+          <p:cNvSpPr/>
+          <p:nvPr/>
+        </p:nvSpPr>
+        <p:spPr>
+          <a:xfrm>
+            <a:off x="6400800" y="1508760"/>
+            <a:ext cx="4663440" cy="3200400"/>
+          </a:xfrm>
+          <a:prstGeom prst="roundRect">
+            <a:avLst/>
+          </a:prstGeom>
+          <a:solidFill>
+            <a:srgbClr val="F7F0F6"/>
+          </a:solidFill>
+          <a:ln>
+            <a:solidFill>
+              <a:srgbClr val="AA7CA7"/>
+            </a:solidFill>
+          </a:ln>
+        </p:spPr>
+        <p:style>
+          <a:lnRef idx="1">
+            <a:schemeClr val="accent1"/>
+          </a:lnRef>
+          <a:fillRef idx="3">
+            <a:schemeClr val="accent1"/>
+          </a:fillRef>
+          <a:effectRef idx="2">
+            <a:schemeClr val="accent1"/>
+          </a:effectRef>
+          <a:fontRef idx="minor">
+            <a:schemeClr val="lt1"/>
+          </a:fontRef>
+        </p:style>
+        <p:txBody>
+          <a:bodyPr rtlCol="0" anchor="ctr"/>
+          <a:lstStyle/>
+          <a:p>
+            <a:pPr algn="ctr"/>
+          </a:p>
+        </p:txBody>
+      </p:sp>
+      <p:sp>
+        <p:nvSpPr>
+          <p:cNvPr id="10" name="TextBox 9"/>
+          <p:cNvSpPr txBox="1"/>
+          <p:nvPr/>
+        </p:nvSpPr>
+        <p:spPr>
+          <a:xfrm>
+            <a:off x="6629400" y="1737360"/>
+            <a:ext cx="4206240" cy="320040"/>
+          </a:xfrm>
+          <a:prstGeom prst="rect">
+            <a:avLst/>
+          </a:prstGeom>
+          <a:noFill/>
+        </p:spPr>
+        <p:txBody>
+          <a:bodyPr wrap="none">
+            <a:spAutoFit/>
+          </a:bodyPr>
+          <a:lstStyle/>
+          <a:p>
+            <a:r>
+              <a:rPr sz="1500" b="1">
+                <a:solidFill>
+                  <a:srgbClr val="72256D"/>
+                </a:solidFill>
+                <a:latin typeface="Aptos"/>
+              </a:rPr>
+              <a:t>Updated workflow</a:t>
+            </a:r>
+          </a:p>
+        </p:txBody>
+      </p:sp>
+      <p:sp>
+        <p:nvSpPr>
+          <p:cNvPr id="11" name="TextBox 10"/>
+          <p:cNvSpPr txBox="1"/>
+          <p:nvPr/>
+        </p:nvSpPr>
+        <p:spPr>
+          <a:xfrm>
+            <a:off x="6629400" y="2194560"/>
+            <a:ext cx="4206240" cy="2286000"/>
+          </a:xfrm>
+          <a:prstGeom prst="rect">
+            <a:avLst/>
+          </a:prstGeom>
+          <a:noFill/>
+        </p:spPr>
+        <p:txBody>
+          <a:bodyPr wrap="none">
+            <a:spAutoFit/>
+          </a:bodyPr>
+          <a:lstStyle/>
+          <a:p>
+            <a:r>
+              <a:rPr sz="1200" b="0">
+                <a:solidFill>
+                  <a:srgbClr val="201A2A"/>
+                </a:solidFill>
+                <a:latin typeface="Aptos"/>
+              </a:rPr>
+              <a:t>Observed gain, tradeoff, and source anchor.</a:t>
+            </a:r>
+          </a:p>
+        </p:txBody>
+      </p:sp>
+    </p:spTree>
+  </p:cSld>
+  <p:clrMapOvr>
+    <a:masterClrMapping/>
+  </p:clrMapOvr>
+</p:sld>
+</file>
+
+<file path=ppt/slides/slide8.xml><?xml version="1.0" encoding="utf-8"?>
+<p:sld xmlns:a="http://schemas.openxmlformats.org/drawingml/2006/main" xmlns:p="http://schemas.openxmlformats.org/presentationml/2006/main" xmlns:r="http://schemas.openxmlformats.org/officeDocument/2006/relationships">
+  <p:cSld>
+    <p:spTree>
+      <p:nvGrpSpPr>
+        <p:cNvPr id="1" name=""/>
+        <p:cNvGrpSpPr/>
+        <p:nvPr/>
+      </p:nvGrpSpPr>
+      <p:grpSpPr/>
+      <p:sp>
+        <p:nvSpPr>
+          <p:cNvPr id="2" name="Rectangle 1"/>
+          <p:cNvSpPr/>
+          <p:nvPr/>
+        </p:nvSpPr>
+        <p:spPr>
+          <a:xfrm>
+            <a:off x="0" y="0"/>
+            <a:ext cx="12191695" cy="384048"/>
+          </a:xfrm>
+          <a:prstGeom prst="rect">
+            <a:avLst/>
+          </a:prstGeom>
+          <a:solidFill>
+            <a:srgbClr val="72256D"/>
+          </a:solidFill>
+          <a:ln>
+            <a:noFill/>
+          </a:ln>
+        </p:spPr>
+        <p:style>
+          <a:lnRef idx="1">
+            <a:schemeClr val="accent1"/>
+          </a:lnRef>
+          <a:fillRef idx="3">
+            <a:schemeClr val="accent1"/>
+          </a:fillRef>
+          <a:effectRef idx="2">
+            <a:schemeClr val="accent1"/>
+          </a:effectRef>
+          <a:fontRef idx="minor">
+            <a:schemeClr val="lt1"/>
+          </a:fontRef>
+        </p:style>
+        <p:txBody>
+          <a:bodyPr rtlCol="0" anchor="ctr"/>
+          <a:lstStyle/>
+          <a:p>
+            <a:pPr algn="ctr"/>
+          </a:p>
+        </p:txBody>
+      </p:sp>
+      <p:sp>
+        <p:nvSpPr>
+          <p:cNvPr id="3" name="TextBox 2"/>
+          <p:cNvSpPr txBox="1"/>
+          <p:nvPr/>
+        </p:nvSpPr>
+        <p:spPr>
+          <a:xfrm>
+            <a:off x="411480" y="73152"/>
+            <a:ext cx="6858000" cy="228600"/>
+          </a:xfrm>
+          <a:prstGeom prst="rect">
+            <a:avLst/>
+          </a:prstGeom>
+          <a:noFill/>
+        </p:spPr>
+        <p:txBody>
+          <a:bodyPr wrap="none">
+            <a:spAutoFit/>
+          </a:bodyPr>
+          <a:lstStyle/>
+          <a:p>
+            <a:r>
+              <a:rPr sz="900" b="0">
+                <a:solidFill>
+                  <a:srgbClr val="FFFFFF"/>
+                </a:solidFill>
+                <a:latin typeface="Aptos"/>
+              </a:rPr>
+              <a:t>Evidence</a:t>
+            </a:r>
+          </a:p>
+        </p:txBody>
+      </p:sp>
+      <p:sp>
+        <p:nvSpPr>
+          <p:cNvPr id="4" name="TextBox 3"/>
+          <p:cNvSpPr txBox="1"/>
+          <p:nvPr/>
+        </p:nvSpPr>
+        <p:spPr>
+          <a:xfrm>
+            <a:off x="10607040" y="73152"/>
+            <a:ext cx="1097280" cy="228600"/>
+          </a:xfrm>
+          <a:prstGeom prst="rect">
+            <a:avLst/>
+          </a:prstGeom>
+          <a:noFill/>
+        </p:spPr>
+        <p:txBody>
+          <a:bodyPr wrap="none">
+            <a:spAutoFit/>
+          </a:bodyPr>
+          <a:lstStyle/>
+          <a:p>
+            <a:r>
+              <a:rPr sz="900" b="0">
+                <a:solidFill>
+                  <a:srgbClr val="FFFFFF"/>
+                </a:solidFill>
+                <a:latin typeface="Aptos"/>
+              </a:rPr>
+              <a:t>8</a:t>
+            </a:r>
+          </a:p>
+        </p:txBody>
+      </p:sp>
+      <p:sp>
+        <p:nvSpPr>
+          <p:cNvPr id="5" name="TextBox 4"/>
+          <p:cNvSpPr txBox="1"/>
+          <p:nvPr/>
+        </p:nvSpPr>
+        <p:spPr>
+          <a:xfrm>
+            <a:off x="594360" y="658368"/>
+            <a:ext cx="9875520" cy="502920"/>
+          </a:xfrm>
+          <a:prstGeom prst="rect">
+            <a:avLst/>
+          </a:prstGeom>
+          <a:noFill/>
+        </p:spPr>
+        <p:txBody>
+          <a:bodyPr wrap="none">
+            <a:spAutoFit/>
+          </a:bodyPr>
+          <a:lstStyle/>
+          <a:p>
+            <a:r>
+              <a:rPr sz="2800" b="1">
+                <a:solidFill>
+                  <a:srgbClr val="201A2A"/>
+                </a:solidFill>
+                <a:latin typeface="Aptos"/>
+              </a:rPr>
+              <a:t>Table Layout</a:t>
+            </a:r>
+          </a:p>
+        </p:txBody>
+      </p:sp>
+      <p:sp>
+        <p:nvSpPr>
+          <p:cNvPr id="6" name="Rectangle 5"/>
+          <p:cNvSpPr/>
+          <p:nvPr/>
+        </p:nvSpPr>
+        <p:spPr>
+          <a:xfrm>
+            <a:off x="914400" y="1417320"/>
+            <a:ext cx="2331720" cy="548640"/>
+          </a:xfrm>
+          <a:prstGeom prst="rect">
+            <a:avLst/>
+          </a:prstGeom>
+          <a:solidFill>
+            <a:srgbClr val="E8E0EC"/>
+          </a:solidFill>
+          <a:ln>
+            <a:solidFill>
+              <a:srgbClr val="AA7CA7"/>
+            </a:solidFill>
+          </a:ln>
+        </p:spPr>
+        <p:style>
+          <a:lnRef idx="1">
+            <a:schemeClr val="accent1"/>
+          </a:lnRef>
+          <a:fillRef idx="3">
+            <a:schemeClr val="accent1"/>
+          </a:fillRef>
+          <a:effectRef idx="2">
+            <a:schemeClr val="accent1"/>
+          </a:effectRef>
+          <a:fontRef idx="minor">
+            <a:schemeClr val="lt1"/>
+          </a:fontRef>
+        </p:style>
+        <p:txBody>
+          <a:bodyPr rtlCol="0" anchor="ctr"/>
+          <a:lstStyle/>
+          <a:p>
+            <a:pPr algn="ctr"/>
+          </a:p>
+        </p:txBody>
+      </p:sp>
+      <p:sp>
+        <p:nvSpPr>
+          <p:cNvPr id="7" name="TextBox 6"/>
+          <p:cNvSpPr txBox="1"/>
+          <p:nvPr/>
+        </p:nvSpPr>
+        <p:spPr>
+          <a:xfrm>
+            <a:off x="1005840" y="1536192"/>
+            <a:ext cx="2103120" cy="228600"/>
+          </a:xfrm>
+          <a:prstGeom prst="rect">
+            <a:avLst/>
+          </a:prstGeom>
+          <a:noFill/>
+        </p:spPr>
+        <p:txBody>
+          <a:bodyPr wrap="none">
+            <a:spAutoFit/>
+          </a:bodyPr>
+          <a:lstStyle/>
+          <a:p>
+            <a:r>
+              <a:rPr sz="1000" b="1">
+                <a:solidFill>
+                  <a:srgbClr val="201A2A"/>
+                </a:solidFill>
+                <a:latin typeface="Aptos"/>
+              </a:rPr>
+              <a:t>Header</a:t>
+            </a:r>
+          </a:p>
+        </p:txBody>
+      </p:sp>
+      <p:sp>
+        <p:nvSpPr>
+          <p:cNvPr id="8" name="Rectangle 7"/>
+          <p:cNvSpPr/>
+          <p:nvPr/>
+        </p:nvSpPr>
+        <p:spPr>
+          <a:xfrm>
+            <a:off x="3291840" y="1417320"/>
+            <a:ext cx="2331720" cy="548640"/>
+          </a:xfrm>
+          <a:prstGeom prst="rect">
+            <a:avLst/>
+          </a:prstGeom>
+          <a:solidFill>
+            <a:srgbClr val="E8E0EC"/>
+          </a:solidFill>
+          <a:ln>
+            <a:solidFill>
+              <a:srgbClr val="AA7CA7"/>
+            </a:solidFill>
+          </a:ln>
+        </p:spPr>
+        <p:style>
+          <a:lnRef idx="1">
+            <a:schemeClr val="accent1"/>
+          </a:lnRef>
+          <a:fillRef idx="3">
+            <a:schemeClr val="accent1"/>
+          </a:fillRef>
+          <a:effectRef idx="2">
+            <a:schemeClr val="accent1"/>
+          </a:effectRef>
+          <a:fontRef idx="minor">
+            <a:schemeClr val="lt1"/>
+          </a:fontRef>
+        </p:style>
+        <p:txBody>
+          <a:bodyPr rtlCol="0" anchor="ctr"/>
+          <a:lstStyle/>
+          <a:p>
+            <a:pPr algn="ctr"/>
+          </a:p>
+        </p:txBody>
+      </p:sp>
+      <p:sp>
+        <p:nvSpPr>
+          <p:cNvPr id="9" name="TextBox 8"/>
+          <p:cNvSpPr txBox="1"/>
+          <p:nvPr/>
+        </p:nvSpPr>
+        <p:spPr>
+          <a:xfrm>
+            <a:off x="3383280" y="1536192"/>
+            <a:ext cx="2103120" cy="228600"/>
+          </a:xfrm>
+          <a:prstGeom prst="rect">
+            <a:avLst/>
+          </a:prstGeom>
+          <a:noFill/>
+        </p:spPr>
+        <p:txBody>
+          <a:bodyPr wrap="none">
+            <a:spAutoFit/>
+          </a:bodyPr>
+          <a:lstStyle/>
+          <a:p>
+            <a:r>
+              <a:rPr sz="1000" b="1">
+                <a:solidFill>
+                  <a:srgbClr val="201A2A"/>
+                </a:solidFill>
+                <a:latin typeface="Aptos"/>
+              </a:rPr>
+              <a:t>Header</a:t>
+            </a:r>
+          </a:p>
+        </p:txBody>
+      </p:sp>
+      <p:sp>
+        <p:nvSpPr>
+          <p:cNvPr id="10" name="Rectangle 9"/>
+          <p:cNvSpPr/>
+          <p:nvPr/>
+        </p:nvSpPr>
+        <p:spPr>
+          <a:xfrm>
+            <a:off x="5669280" y="1417320"/>
+            <a:ext cx="2331720" cy="548640"/>
+          </a:xfrm>
+          <a:prstGeom prst="rect">
+            <a:avLst/>
+          </a:prstGeom>
+          <a:solidFill>
+            <a:srgbClr val="E8E0EC"/>
+          </a:solidFill>
+          <a:ln>
+            <a:solidFill>
+              <a:srgbClr val="AA7CA7"/>
+            </a:solidFill>
+          </a:ln>
+        </p:spPr>
+        <p:style>
+          <a:lnRef idx="1">
+            <a:schemeClr val="accent1"/>
+          </a:lnRef>
+          <a:fillRef idx="3">
+            <a:schemeClr val="accent1"/>
+          </a:fillRef>
+          <a:effectRef idx="2">
+            <a:schemeClr val="accent1"/>
+          </a:effectRef>
+          <a:fontRef idx="minor">
+            <a:schemeClr val="lt1"/>
+          </a:fontRef>
+        </p:style>
+        <p:txBody>
+          <a:bodyPr rtlCol="0" anchor="ctr"/>
+          <a:lstStyle/>
+          <a:p>
+            <a:pPr algn="ctr"/>
+          </a:p>
+        </p:txBody>
+      </p:sp>
+      <p:sp>
+        <p:nvSpPr>
+          <p:cNvPr id="11" name="TextBox 10"/>
+          <p:cNvSpPr txBox="1"/>
+          <p:nvPr/>
+        </p:nvSpPr>
+        <p:spPr>
+          <a:xfrm>
+            <a:off x="5760720" y="1536192"/>
+            <a:ext cx="2103120" cy="228600"/>
+          </a:xfrm>
+          <a:prstGeom prst="rect">
+            <a:avLst/>
+          </a:prstGeom>
+          <a:noFill/>
+        </p:spPr>
+        <p:txBody>
+          <a:bodyPr wrap="none">
+            <a:spAutoFit/>
+          </a:bodyPr>
+          <a:lstStyle/>
+          <a:p>
+            <a:r>
+              <a:rPr sz="1000" b="1">
+                <a:solidFill>
+                  <a:srgbClr val="201A2A"/>
+                </a:solidFill>
+                <a:latin typeface="Aptos"/>
+              </a:rPr>
+              <a:t>Header</a:t>
+            </a:r>
+          </a:p>
+        </p:txBody>
+      </p:sp>
+      <p:sp>
+        <p:nvSpPr>
+          <p:cNvPr id="12" name="Rectangle 11"/>
+          <p:cNvSpPr/>
+          <p:nvPr/>
+        </p:nvSpPr>
+        <p:spPr>
+          <a:xfrm>
+            <a:off x="8046720" y="1417320"/>
+            <a:ext cx="2331720" cy="548640"/>
+          </a:xfrm>
+          <a:prstGeom prst="rect">
+            <a:avLst/>
+          </a:prstGeom>
+          <a:solidFill>
+            <a:srgbClr val="E8E0EC"/>
+          </a:solidFill>
+          <a:ln>
+            <a:solidFill>
+              <a:srgbClr val="AA7CA7"/>
+            </a:solidFill>
+          </a:ln>
+        </p:spPr>
+        <p:style>
+          <a:lnRef idx="1">
+            <a:schemeClr val="accent1"/>
+          </a:lnRef>
+          <a:fillRef idx="3">
+            <a:schemeClr val="accent1"/>
+          </a:fillRef>
+          <a:effectRef idx="2">
+            <a:schemeClr val="accent1"/>
+          </a:effectRef>
+          <a:fontRef idx="minor">
+            <a:schemeClr val="lt1"/>
+          </a:fontRef>
+        </p:style>
+        <p:txBody>
+          <a:bodyPr rtlCol="0" anchor="ctr"/>
+          <a:lstStyle/>
+          <a:p>
+            <a:pPr algn="ctr"/>
+          </a:p>
+        </p:txBody>
+      </p:sp>
+      <p:sp>
+        <p:nvSpPr>
+          <p:cNvPr id="13" name="TextBox 12"/>
+          <p:cNvSpPr txBox="1"/>
+          <p:nvPr/>
+        </p:nvSpPr>
+        <p:spPr>
+          <a:xfrm>
+            <a:off x="8138160" y="1536192"/>
+            <a:ext cx="2103120" cy="228600"/>
+          </a:xfrm>
+          <a:prstGeom prst="rect">
+            <a:avLst/>
+          </a:prstGeom>
+          <a:noFill/>
+        </p:spPr>
+        <p:txBody>
+          <a:bodyPr wrap="none">
+            <a:spAutoFit/>
+          </a:bodyPr>
+          <a:lstStyle/>
+          <a:p>
+            <a:r>
+              <a:rPr sz="1000" b="1">
+                <a:solidFill>
+                  <a:srgbClr val="201A2A"/>
+                </a:solidFill>
+                <a:latin typeface="Aptos"/>
+              </a:rPr>
+              <a:t>Header</a:t>
+            </a:r>
+          </a:p>
+        </p:txBody>
+      </p:sp>
+      <p:sp>
+        <p:nvSpPr>
+          <p:cNvPr id="14" name="Rectangle 13"/>
+          <p:cNvSpPr/>
+          <p:nvPr/>
+        </p:nvSpPr>
+        <p:spPr>
+          <a:xfrm>
+            <a:off x="914400" y="2011680"/>
+            <a:ext cx="2331720" cy="548640"/>
+          </a:xfrm>
+          <a:prstGeom prst="rect">
+            <a:avLst/>
+          </a:prstGeom>
+          <a:solidFill>
+            <a:srgbClr val="FFFFFF"/>
+          </a:solidFill>
+          <a:ln>
+            <a:solidFill>
+              <a:srgbClr val="AA7CA7"/>
+            </a:solidFill>
+          </a:ln>
+        </p:spPr>
+        <p:style>
+          <a:lnRef idx="1">
+            <a:schemeClr val="accent1"/>
+          </a:lnRef>
+          <a:fillRef idx="3">
+            <a:schemeClr val="accent1"/>
+          </a:fillRef>
+          <a:effectRef idx="2">
+            <a:schemeClr val="accent1"/>
+          </a:effectRef>
+          <a:fontRef idx="minor">
+            <a:schemeClr val="lt1"/>
+          </a:fontRef>
+        </p:style>
+        <p:txBody>
+          <a:bodyPr rtlCol="0" anchor="ctr"/>
+          <a:lstStyle/>
+          <a:p>
+            <a:pPr algn="ctr"/>
+          </a:p>
+        </p:txBody>
+      </p:sp>
+      <p:sp>
+        <p:nvSpPr>
+          <p:cNvPr id="15" name="TextBox 14"/>
+          <p:cNvSpPr txBox="1"/>
+          <p:nvPr/>
+        </p:nvSpPr>
+        <p:spPr>
+          <a:xfrm>
+            <a:off x="1005840" y="2130552"/>
+            <a:ext cx="2103120" cy="228600"/>
+          </a:xfrm>
+          <a:prstGeom prst="rect">
+            <a:avLst/>
+          </a:prstGeom>
+          <a:noFill/>
+        </p:spPr>
+        <p:txBody>
+          <a:bodyPr wrap="none">
+            <a:spAutoFit/>
+          </a:bodyPr>
+          <a:lstStyle/>
+          <a:p>
+            <a:r>
+              <a:rPr sz="1000" b="0">
+                <a:solidFill>
+                  <a:srgbClr val="201A2A"/>
+                </a:solidFill>
+                <a:latin typeface="Aptos"/>
+              </a:rPr>
+              <a:t>Value</a:t>
+            </a:r>
+          </a:p>
+        </p:txBody>
+      </p:sp>
+      <p:sp>
+        <p:nvSpPr>
+          <p:cNvPr id="16" name="Rectangle 15"/>
+          <p:cNvSpPr/>
+          <p:nvPr/>
+        </p:nvSpPr>
+        <p:spPr>
+          <a:xfrm>
+            <a:off x="3291840" y="2011680"/>
+            <a:ext cx="2331720" cy="548640"/>
+          </a:xfrm>
+          <a:prstGeom prst="rect">
+            <a:avLst/>
+          </a:prstGeom>
+          <a:solidFill>
+            <a:srgbClr val="FFFFFF"/>
+          </a:solidFill>
+          <a:ln>
+            <a:solidFill>
+              <a:srgbClr val="AA7CA7"/>
+            </a:solidFill>
+          </a:ln>
+        </p:spPr>
+        <p:style>
+          <a:lnRef idx="1">
+            <a:schemeClr val="accent1"/>
+          </a:lnRef>
+          <a:fillRef idx="3">
+            <a:schemeClr val="accent1"/>
+          </a:fillRef>
+          <a:effectRef idx="2">
+            <a:schemeClr val="accent1"/>
+          </a:effectRef>
+          <a:fontRef idx="minor">
+            <a:schemeClr val="lt1"/>
+          </a:fontRef>
+        </p:style>
+        <p:txBody>
+          <a:bodyPr rtlCol="0" anchor="ctr"/>
+          <a:lstStyle/>
+          <a:p>
+            <a:pPr algn="ctr"/>
+          </a:p>
+        </p:txBody>
+      </p:sp>
+      <p:sp>
+        <p:nvSpPr>
+          <p:cNvPr id="17" name="TextBox 16"/>
+          <p:cNvSpPr txBox="1"/>
+          <p:nvPr/>
+        </p:nvSpPr>
+        <p:spPr>
+          <a:xfrm>
+            <a:off x="3383280" y="2130552"/>
+            <a:ext cx="2103120" cy="228600"/>
+          </a:xfrm>
+          <a:prstGeom prst="rect">
+            <a:avLst/>
+          </a:prstGeom>
+          <a:noFill/>
+        </p:spPr>
+        <p:txBody>
+          <a:bodyPr wrap="none">
+            <a:spAutoFit/>
+          </a:bodyPr>
+          <a:lstStyle/>
+          <a:p>
+            <a:r>
+              <a:rPr sz="1000" b="0">
+                <a:solidFill>
+                  <a:srgbClr val="201A2A"/>
+                </a:solidFill>
+                <a:latin typeface="Aptos"/>
+              </a:rPr>
+              <a:t>Value</a:t>
+            </a:r>
+          </a:p>
+        </p:txBody>
+      </p:sp>
+      <p:sp>
+        <p:nvSpPr>
+          <p:cNvPr id="18" name="Rectangle 17"/>
+          <p:cNvSpPr/>
+          <p:nvPr/>
+        </p:nvSpPr>
+        <p:spPr>
+          <a:xfrm>
+            <a:off x="5669280" y="2011680"/>
+            <a:ext cx="2331720" cy="548640"/>
+          </a:xfrm>
+          <a:prstGeom prst="rect">
+            <a:avLst/>
+          </a:prstGeom>
+          <a:solidFill>
+            <a:srgbClr val="FFFFFF"/>
+          </a:solidFill>
+          <a:ln>
+            <a:solidFill>
+              <a:srgbClr val="AA7CA7"/>
+            </a:solidFill>
+          </a:ln>
+        </p:spPr>
+        <p:style>
+          <a:lnRef idx="1">
+            <a:schemeClr val="accent1"/>
+          </a:lnRef>
+          <a:fillRef idx="3">
+            <a:schemeClr val="accent1"/>
+          </a:fillRef>
+          <a:effectRef idx="2">
+            <a:schemeClr val="accent1"/>
+          </a:effectRef>
+          <a:fontRef idx="minor">
+            <a:schemeClr val="lt1"/>
+          </a:fontRef>
+        </p:style>
+        <p:txBody>
+          <a:bodyPr rtlCol="0" anchor="ctr"/>
+          <a:lstStyle/>
+          <a:p>
+            <a:pPr algn="ctr"/>
+          </a:p>
+        </p:txBody>
+      </p:sp>
+      <p:sp>
+        <p:nvSpPr>
+          <p:cNvPr id="19" name="TextBox 18"/>
+          <p:cNvSpPr txBox="1"/>
+          <p:nvPr/>
+        </p:nvSpPr>
+        <p:spPr>
+          <a:xfrm>
+            <a:off x="5760720" y="2130552"/>
+            <a:ext cx="2103120" cy="228600"/>
+          </a:xfrm>
+          <a:prstGeom prst="rect">
+            <a:avLst/>
+          </a:prstGeom>
+          <a:noFill/>
+        </p:spPr>
+        <p:txBody>
+          <a:bodyPr wrap="none">
+            <a:spAutoFit/>
+          </a:bodyPr>
+          <a:lstStyle/>
+          <a:p>
+            <a:r>
+              <a:rPr sz="1000" b="0">
+                <a:solidFill>
+                  <a:srgbClr val="201A2A"/>
+                </a:solidFill>
+                <a:latin typeface="Aptos"/>
+              </a:rPr>
+              <a:t>Value</a:t>
+            </a:r>
+          </a:p>
+        </p:txBody>
+      </p:sp>
+      <p:sp>
+        <p:nvSpPr>
+          <p:cNvPr id="20" name="Rectangle 19"/>
+          <p:cNvSpPr/>
+          <p:nvPr/>
+        </p:nvSpPr>
+        <p:spPr>
+          <a:xfrm>
+            <a:off x="8046720" y="2011680"/>
+            <a:ext cx="2331720" cy="548640"/>
+          </a:xfrm>
+          <a:prstGeom prst="rect">
+            <a:avLst/>
+          </a:prstGeom>
+          <a:solidFill>
+            <a:srgbClr val="FFFFFF"/>
+          </a:solidFill>
+          <a:ln>
+            <a:solidFill>
+              <a:srgbClr val="AA7CA7"/>
+            </a:solidFill>
+          </a:ln>
+        </p:spPr>
+        <p:style>
+          <a:lnRef idx="1">
+            <a:schemeClr val="accent1"/>
+          </a:lnRef>
+          <a:fillRef idx="3">
+            <a:schemeClr val="accent1"/>
+          </a:fillRef>
+          <a:effectRef idx="2">
+            <a:schemeClr val="accent1"/>
+          </a:effectRef>
+          <a:fontRef idx="minor">
+            <a:schemeClr val="lt1"/>
+          </a:fontRef>
+        </p:style>
+        <p:txBody>
+          <a:bodyPr rtlCol="0" anchor="ctr"/>
+          <a:lstStyle/>
+          <a:p>
+            <a:pPr algn="ctr"/>
+          </a:p>
+        </p:txBody>
+      </p:sp>
+      <p:sp>
+        <p:nvSpPr>
+          <p:cNvPr id="21" name="TextBox 20"/>
+          <p:cNvSpPr txBox="1"/>
+          <p:nvPr/>
+        </p:nvSpPr>
+        <p:spPr>
+          <a:xfrm>
+            <a:off x="8138160" y="2130552"/>
+            <a:ext cx="2103120" cy="228600"/>
+          </a:xfrm>
+          <a:prstGeom prst="rect">
+            <a:avLst/>
+          </a:prstGeom>
+          <a:noFill/>
+        </p:spPr>
+        <p:txBody>
+          <a:bodyPr wrap="none">
+            <a:spAutoFit/>
+          </a:bodyPr>
+          <a:lstStyle/>
+          <a:p>
+            <a:r>
+              <a:rPr sz="1000" b="0">
+                <a:solidFill>
+                  <a:srgbClr val="201A2A"/>
+                </a:solidFill>
+                <a:latin typeface="Aptos"/>
+              </a:rPr>
+              <a:t>Value</a:t>
+            </a:r>
+          </a:p>
+        </p:txBody>
+      </p:sp>
+      <p:sp>
+        <p:nvSpPr>
+          <p:cNvPr id="22" name="Rectangle 21"/>
+          <p:cNvSpPr/>
+          <p:nvPr/>
+        </p:nvSpPr>
+        <p:spPr>
+          <a:xfrm>
+            <a:off x="914400" y="2606040"/>
+            <a:ext cx="2331720" cy="548640"/>
+          </a:xfrm>
+          <a:prstGeom prst="rect">
+            <a:avLst/>
+          </a:prstGeom>
+          <a:solidFill>
+            <a:srgbClr val="FFFFFF"/>
+          </a:solidFill>
+          <a:ln>
+            <a:solidFill>
+              <a:srgbClr val="AA7CA7"/>
+            </a:solidFill>
+          </a:ln>
+        </p:spPr>
+        <p:style>
+          <a:lnRef idx="1">
+            <a:schemeClr val="accent1"/>
+          </a:lnRef>
+          <a:fillRef idx="3">
+            <a:schemeClr val="accent1"/>
+          </a:fillRef>
+          <a:effectRef idx="2">
+            <a:schemeClr val="accent1"/>
+          </a:effectRef>
+          <a:fontRef idx="minor">
+            <a:schemeClr val="lt1"/>
+          </a:fontRef>
+        </p:style>
+        <p:txBody>
+          <a:bodyPr rtlCol="0" anchor="ctr"/>
+          <a:lstStyle/>
+          <a:p>
+            <a:pPr algn="ctr"/>
+          </a:p>
+        </p:txBody>
+      </p:sp>
+      <p:sp>
+        <p:nvSpPr>
+          <p:cNvPr id="23" name="TextBox 22"/>
+          <p:cNvSpPr txBox="1"/>
+          <p:nvPr/>
+        </p:nvSpPr>
+        <p:spPr>
+          <a:xfrm>
+            <a:off x="1005840" y="2724912"/>
+            <a:ext cx="2103120" cy="228600"/>
+          </a:xfrm>
+          <a:prstGeom prst="rect">
+            <a:avLst/>
+          </a:prstGeom>
+          <a:noFill/>
+        </p:spPr>
+        <p:txBody>
+          <a:bodyPr wrap="none">
+            <a:spAutoFit/>
+          </a:bodyPr>
+          <a:lstStyle/>
+          <a:p>
+            <a:r>
+              <a:rPr sz="1000" b="0">
+                <a:solidFill>
+                  <a:srgbClr val="201A2A"/>
+                </a:solidFill>
+                <a:latin typeface="Aptos"/>
+              </a:rPr>
+              <a:t>Value</a:t>
+            </a:r>
+          </a:p>
+        </p:txBody>
+      </p:sp>
+      <p:sp>
+        <p:nvSpPr>
+          <p:cNvPr id="24" name="Rectangle 23"/>
+          <p:cNvSpPr/>
+          <p:nvPr/>
+        </p:nvSpPr>
+        <p:spPr>
+          <a:xfrm>
+            <a:off x="3291840" y="2606040"/>
+            <a:ext cx="2331720" cy="548640"/>
+          </a:xfrm>
+          <a:prstGeom prst="rect">
+            <a:avLst/>
+          </a:prstGeom>
+          <a:solidFill>
+            <a:srgbClr val="FFFFFF"/>
+          </a:solidFill>
+          <a:ln>
+            <a:solidFill>
+              <a:srgbClr val="AA7CA7"/>
+            </a:solidFill>
+          </a:ln>
+        </p:spPr>
+        <p:style>
+          <a:lnRef idx="1">
+            <a:schemeClr val="accent1"/>
+          </a:lnRef>
+          <a:fillRef idx="3">
+            <a:schemeClr val="accent1"/>
+          </a:fillRef>
+          <a:effectRef idx="2">
+            <a:schemeClr val="accent1"/>
+          </a:effectRef>
+          <a:fontRef idx="minor">
+            <a:schemeClr val="lt1"/>
+          </a:fontRef>
+        </p:style>
+        <p:txBody>
+          <a:bodyPr rtlCol="0" anchor="ctr"/>
+          <a:lstStyle/>
+          <a:p>
+            <a:pPr algn="ctr"/>
+          </a:p>
+        </p:txBody>
+      </p:sp>
+      <p:sp>
+        <p:nvSpPr>
+          <p:cNvPr id="25" name="TextBox 24"/>
+          <p:cNvSpPr txBox="1"/>
+          <p:nvPr/>
+        </p:nvSpPr>
+        <p:spPr>
+          <a:xfrm>
+            <a:off x="3383280" y="2724912"/>
+            <a:ext cx="2103120" cy="228600"/>
+          </a:xfrm>
+          <a:prstGeom prst="rect">
+            <a:avLst/>
+          </a:prstGeom>
+          <a:noFill/>
+        </p:spPr>
+        <p:txBody>
+          <a:bodyPr wrap="none">
+            <a:spAutoFit/>
+          </a:bodyPr>
+          <a:lstStyle/>
+          <a:p>
+            <a:r>
+              <a:rPr sz="1000" b="0">
+                <a:solidFill>
+                  <a:srgbClr val="201A2A"/>
+                </a:solidFill>
+                <a:latin typeface="Aptos"/>
+              </a:rPr>
+              <a:t>Value</a:t>
+            </a:r>
+          </a:p>
+        </p:txBody>
+      </p:sp>
+      <p:sp>
+        <p:nvSpPr>
+          <p:cNvPr id="26" name="Rectangle 25"/>
+          <p:cNvSpPr/>
+          <p:nvPr/>
+        </p:nvSpPr>
+        <p:spPr>
+          <a:xfrm>
+            <a:off x="5669280" y="2606040"/>
+            <a:ext cx="2331720" cy="548640"/>
+          </a:xfrm>
+          <a:prstGeom prst="rect">
+            <a:avLst/>
+          </a:prstGeom>
+          <a:solidFill>
+            <a:srgbClr val="FFFFFF"/>
+          </a:solidFill>
+          <a:ln>
+            <a:solidFill>
+              <a:srgbClr val="AA7CA7"/>
+            </a:solidFill>
+          </a:ln>
+        </p:spPr>
+        <p:style>
+          <a:lnRef idx="1">
+            <a:schemeClr val="accent1"/>
+          </a:lnRef>
+          <a:fillRef idx="3">
+            <a:schemeClr val="accent1"/>
+          </a:fillRef>
+          <a:effectRef idx="2">
+            <a:schemeClr val="accent1"/>
+          </a:effectRef>
+          <a:fontRef idx="minor">
+            <a:schemeClr val="lt1"/>
+          </a:fontRef>
+        </p:style>
+        <p:txBody>
+          <a:bodyPr rtlCol="0" anchor="ctr"/>
+          <a:lstStyle/>
+          <a:p>
+            <a:pPr algn="ctr"/>
+          </a:p>
+        </p:txBody>
+      </p:sp>
+      <p:sp>
+        <p:nvSpPr>
+          <p:cNvPr id="27" name="TextBox 26"/>
+          <p:cNvSpPr txBox="1"/>
+          <p:nvPr/>
+        </p:nvSpPr>
+        <p:spPr>
+          <a:xfrm>
+            <a:off x="5760720" y="2724912"/>
+            <a:ext cx="2103120" cy="228600"/>
+          </a:xfrm>
+          <a:prstGeom prst="rect">
+            <a:avLst/>
+          </a:prstGeom>
+          <a:noFill/>
+        </p:spPr>
+        <p:txBody>
+          <a:bodyPr wrap="none">
+            <a:spAutoFit/>
+          </a:bodyPr>
+          <a:lstStyle/>
+          <a:p>
+            <a:r>
+              <a:rPr sz="1000" b="0">
+                <a:solidFill>
+                  <a:srgbClr val="201A2A"/>
+                </a:solidFill>
+                <a:latin typeface="Aptos"/>
+              </a:rPr>
+              <a:t>Value</a:t>
+            </a:r>
+          </a:p>
+        </p:txBody>
+      </p:sp>
+      <p:sp>
+        <p:nvSpPr>
+          <p:cNvPr id="28" name="Rectangle 27"/>
+          <p:cNvSpPr/>
+          <p:nvPr/>
+        </p:nvSpPr>
+        <p:spPr>
+          <a:xfrm>
+            <a:off x="8046720" y="2606040"/>
+            <a:ext cx="2331720" cy="548640"/>
+          </a:xfrm>
+          <a:prstGeom prst="rect">
+            <a:avLst/>
+          </a:prstGeom>
+          <a:solidFill>
+            <a:srgbClr val="FFFFFF"/>
+          </a:solidFill>
+          <a:ln>
+            <a:solidFill>
+              <a:srgbClr val="AA7CA7"/>
+            </a:solidFill>
+          </a:ln>
+        </p:spPr>
+        <p:style>
+          <a:lnRef idx="1">
+            <a:schemeClr val="accent1"/>
+          </a:lnRef>
+          <a:fillRef idx="3">
+            <a:schemeClr val="accent1"/>
+          </a:fillRef>
+          <a:effectRef idx="2">
+            <a:schemeClr val="accent1"/>
+          </a:effectRef>
+          <a:fontRef idx="minor">
+            <a:schemeClr val="lt1"/>
+          </a:fontRef>
+        </p:style>
+        <p:txBody>
+          <a:bodyPr rtlCol="0" anchor="ctr"/>
+          <a:lstStyle/>
+          <a:p>
+            <a:pPr algn="ctr"/>
+          </a:p>
+        </p:txBody>
+      </p:sp>
+      <p:sp>
+        <p:nvSpPr>
+          <p:cNvPr id="29" name="TextBox 28"/>
+          <p:cNvSpPr txBox="1"/>
+          <p:nvPr/>
+        </p:nvSpPr>
+        <p:spPr>
+          <a:xfrm>
+            <a:off x="8138160" y="2724912"/>
+            <a:ext cx="2103120" cy="228600"/>
+          </a:xfrm>
+          <a:prstGeom prst="rect">
+            <a:avLst/>
+          </a:prstGeom>
+          <a:noFill/>
+        </p:spPr>
+        <p:txBody>
+          <a:bodyPr wrap="none">
+            <a:spAutoFit/>
+          </a:bodyPr>
+          <a:lstStyle/>
+          <a:p>
+            <a:r>
+              <a:rPr sz="1000" b="0">
+                <a:solidFill>
+                  <a:srgbClr val="201A2A"/>
+                </a:solidFill>
+                <a:latin typeface="Aptos"/>
+              </a:rPr>
+              <a:t>Value</a:t>
+            </a:r>
+          </a:p>
+        </p:txBody>
+      </p:sp>
+      <p:sp>
+        <p:nvSpPr>
+          <p:cNvPr id="30" name="Rectangle 29"/>
+          <p:cNvSpPr/>
+          <p:nvPr/>
+        </p:nvSpPr>
+        <p:spPr>
+          <a:xfrm>
+            <a:off x="914400" y="3200400"/>
+            <a:ext cx="2331720" cy="548640"/>
+          </a:xfrm>
+          <a:prstGeom prst="rect">
+            <a:avLst/>
+          </a:prstGeom>
+          <a:solidFill>
+            <a:srgbClr val="FFFFFF"/>
+          </a:solidFill>
+          <a:ln>
+            <a:solidFill>
+              <a:srgbClr val="AA7CA7"/>
+            </a:solidFill>
+          </a:ln>
+        </p:spPr>
+        <p:style>
+          <a:lnRef idx="1">
+            <a:schemeClr val="accent1"/>
+          </a:lnRef>
+          <a:fillRef idx="3">
+            <a:schemeClr val="accent1"/>
+          </a:fillRef>
+          <a:effectRef idx="2">
+            <a:schemeClr val="accent1"/>
+          </a:effectRef>
+          <a:fontRef idx="minor">
+            <a:schemeClr val="lt1"/>
+          </a:fontRef>
+        </p:style>
+        <p:txBody>
+          <a:bodyPr rtlCol="0" anchor="ctr"/>
+          <a:lstStyle/>
+          <a:p>
+            <a:pPr algn="ctr"/>
+          </a:p>
+        </p:txBody>
+      </p:sp>
+      <p:sp>
+        <p:nvSpPr>
+          <p:cNvPr id="31" name="TextBox 30"/>
+          <p:cNvSpPr txBox="1"/>
+          <p:nvPr/>
+        </p:nvSpPr>
+        <p:spPr>
+          <a:xfrm>
+            <a:off x="1005840" y="3319272"/>
+            <a:ext cx="2103120" cy="228600"/>
+          </a:xfrm>
+          <a:prstGeom prst="rect">
+            <a:avLst/>
+          </a:prstGeom>
+          <a:noFill/>
+        </p:spPr>
+        <p:txBody>
+          <a:bodyPr wrap="none">
+            <a:spAutoFit/>
+          </a:bodyPr>
+          <a:lstStyle/>
+          <a:p>
+            <a:r>
+              <a:rPr sz="1000" b="0">
+                <a:solidFill>
+                  <a:srgbClr val="201A2A"/>
+                </a:solidFill>
+                <a:latin typeface="Aptos"/>
+              </a:rPr>
+              <a:t>Value</a:t>
+            </a:r>
+          </a:p>
+        </p:txBody>
+      </p:sp>
+      <p:sp>
+        <p:nvSpPr>
+          <p:cNvPr id="32" name="Rectangle 31"/>
+          <p:cNvSpPr/>
+          <p:nvPr/>
+        </p:nvSpPr>
+        <p:spPr>
+          <a:xfrm>
+            <a:off x="3291840" y="3200400"/>
+            <a:ext cx="2331720" cy="548640"/>
+          </a:xfrm>
+          <a:prstGeom prst="rect">
+            <a:avLst/>
+          </a:prstGeom>
+          <a:solidFill>
+            <a:srgbClr val="FFFFFF"/>
+          </a:solidFill>
+          <a:ln>
+            <a:solidFill>
+              <a:srgbClr val="AA7CA7"/>
+            </a:solidFill>
+          </a:ln>
+        </p:spPr>
+        <p:style>
+          <a:lnRef idx="1">
+            <a:schemeClr val="accent1"/>
+          </a:lnRef>
+          <a:fillRef idx="3">
+            <a:schemeClr val="accent1"/>
+          </a:fillRef>
+          <a:effectRef idx="2">
+            <a:schemeClr val="accent1"/>
+          </a:effectRef>
+          <a:fontRef idx="minor">
+            <a:schemeClr val="lt1"/>
+          </a:fontRef>
+        </p:style>
+        <p:txBody>
+          <a:bodyPr rtlCol="0" anchor="ctr"/>
+          <a:lstStyle/>
+          <a:p>
+            <a:pPr algn="ctr"/>
+          </a:p>
+        </p:txBody>
+      </p:sp>
+      <p:sp>
+        <p:nvSpPr>
+          <p:cNvPr id="33" name="TextBox 32"/>
+          <p:cNvSpPr txBox="1"/>
+          <p:nvPr/>
+        </p:nvSpPr>
+        <p:spPr>
+          <a:xfrm>
+            <a:off x="3383280" y="3319272"/>
+            <a:ext cx="2103120" cy="228600"/>
+          </a:xfrm>
+          <a:prstGeom prst="rect">
+            <a:avLst/>
+          </a:prstGeom>
+          <a:noFill/>
+        </p:spPr>
+        <p:txBody>
+          <a:bodyPr wrap="none">
+            <a:spAutoFit/>
+          </a:bodyPr>
+          <a:lstStyle/>
+          <a:p>
+            <a:r>
+              <a:rPr sz="1000" b="0">
+                <a:solidFill>
+                  <a:srgbClr val="201A2A"/>
+                </a:solidFill>
+                <a:latin typeface="Aptos"/>
+              </a:rPr>
+              <a:t>Value</a:t>
+            </a:r>
+          </a:p>
+        </p:txBody>
+      </p:sp>
+      <p:sp>
+        <p:nvSpPr>
+          <p:cNvPr id="34" name="Rectangle 33"/>
+          <p:cNvSpPr/>
+          <p:nvPr/>
+        </p:nvSpPr>
+        <p:spPr>
+          <a:xfrm>
+            <a:off x="5669280" y="3200400"/>
+            <a:ext cx="2331720" cy="548640"/>
+          </a:xfrm>
+          <a:prstGeom prst="rect">
+            <a:avLst/>
+          </a:prstGeom>
+          <a:solidFill>
+            <a:srgbClr val="FFFFFF"/>
+          </a:solidFill>
+          <a:ln>
+            <a:solidFill>
+              <a:srgbClr val="AA7CA7"/>
+            </a:solidFill>
+          </a:ln>
+        </p:spPr>
+        <p:style>
+          <a:lnRef idx="1">
+            <a:schemeClr val="accent1"/>
+          </a:lnRef>
+          <a:fillRef idx="3">
+            <a:schemeClr val="accent1"/>
+          </a:fillRef>
+          <a:effectRef idx="2">
+            <a:schemeClr val="accent1"/>
+          </a:effectRef>
+          <a:fontRef idx="minor">
+            <a:schemeClr val="lt1"/>
+          </a:fontRef>
+        </p:style>
+        <p:txBody>
+          <a:bodyPr rtlCol="0" anchor="ctr"/>
+          <a:lstStyle/>
+          <a:p>
+            <a:pPr algn="ctr"/>
+          </a:p>
+        </p:txBody>
+      </p:sp>
+      <p:sp>
+        <p:nvSpPr>
+          <p:cNvPr id="35" name="TextBox 34"/>
+          <p:cNvSpPr txBox="1"/>
+          <p:nvPr/>
+        </p:nvSpPr>
+        <p:spPr>
+          <a:xfrm>
+            <a:off x="5760720" y="3319272"/>
+            <a:ext cx="2103120" cy="228600"/>
+          </a:xfrm>
+          <a:prstGeom prst="rect">
+            <a:avLst/>
+          </a:prstGeom>
+          <a:noFill/>
+        </p:spPr>
+        <p:txBody>
+          <a:bodyPr wrap="none">
+            <a:spAutoFit/>
+          </a:bodyPr>
+          <a:lstStyle/>
+          <a:p>
+            <a:r>
+              <a:rPr sz="1000" b="0">
+                <a:solidFill>
+                  <a:srgbClr val="201A2A"/>
+                </a:solidFill>
+                <a:latin typeface="Aptos"/>
+              </a:rPr>
+              <a:t>Value</a:t>
+            </a:r>
+          </a:p>
+        </p:txBody>
+      </p:sp>
+      <p:sp>
+        <p:nvSpPr>
+          <p:cNvPr id="36" name="Rectangle 35"/>
+          <p:cNvSpPr/>
+          <p:nvPr/>
+        </p:nvSpPr>
+        <p:spPr>
+          <a:xfrm>
+            <a:off x="8046720" y="3200400"/>
+            <a:ext cx="2331720" cy="548640"/>
+          </a:xfrm>
+          <a:prstGeom prst="rect">
+            <a:avLst/>
+          </a:prstGeom>
+          <a:solidFill>
+            <a:srgbClr val="FFFFFF"/>
+          </a:solidFill>
+          <a:ln>
+            <a:solidFill>
+              <a:srgbClr val="AA7CA7"/>
+            </a:solidFill>
+          </a:ln>
+        </p:spPr>
+        <p:style>
+          <a:lnRef idx="1">
+            <a:schemeClr val="accent1"/>
+          </a:lnRef>
+          <a:fillRef idx="3">
+            <a:schemeClr val="accent1"/>
+          </a:fillRef>
+          <a:effectRef idx="2">
+            <a:schemeClr val="accent1"/>
+          </a:effectRef>
+          <a:fontRef idx="minor">
+            <a:schemeClr val="lt1"/>
+          </a:fontRef>
+        </p:style>
+        <p:txBody>
+          <a:bodyPr rtlCol="0" anchor="ctr"/>
+          <a:lstStyle/>
+          <a:p>
+            <a:pPr algn="ctr"/>
+          </a:p>
+        </p:txBody>
+      </p:sp>
+      <p:sp>
+        <p:nvSpPr>
+          <p:cNvPr id="37" name="TextBox 36"/>
+          <p:cNvSpPr txBox="1"/>
+          <p:nvPr/>
+        </p:nvSpPr>
+        <p:spPr>
+          <a:xfrm>
+            <a:off x="8138160" y="3319272"/>
+            <a:ext cx="2103120" cy="228600"/>
+          </a:xfrm>
+          <a:prstGeom prst="rect">
+            <a:avLst/>
+          </a:prstGeom>
+          <a:noFill/>
+        </p:spPr>
+        <p:txBody>
+          <a:bodyPr wrap="none">
+            <a:spAutoFit/>
+          </a:bodyPr>
+          <a:lstStyle/>
+          <a:p>
+            <a:r>
+              <a:rPr sz="1000" b="0">
+                <a:solidFill>
+                  <a:srgbClr val="201A2A"/>
+                </a:solidFill>
+                <a:latin typeface="Aptos"/>
+              </a:rPr>
+              <a:t>Value</a:t>
+            </a:r>
+          </a:p>
+        </p:txBody>
+      </p:sp>
+    </p:spTree>
+  </p:cSld>
+  <p:clrMapOvr>
+    <a:masterClrMapping/>
+  </p:clrMapOvr>
+</p:sld>
+</file>
+
+<file path=ppt/slides/slide9.xml><?xml version="1.0" encoding="utf-8"?>
+<p:sld xmlns:a="http://schemas.openxmlformats.org/drawingml/2006/main" xmlns:p="http://schemas.openxmlformats.org/presentationml/2006/main" xmlns:r="http://schemas.openxmlformats.org/officeDocument/2006/relationships">
+  <p:cSld>
+    <p:spTree>
+      <p:nvGrpSpPr>
+        <p:cNvPr id="1" name=""/>
+        <p:cNvGrpSpPr/>
+        <p:nvPr/>
+      </p:nvGrpSpPr>
+      <p:grpSpPr/>
+      <p:sp>
+        <p:nvSpPr>
+          <p:cNvPr id="2" name="Rectangle 1"/>
+          <p:cNvSpPr/>
+          <p:nvPr/>
+        </p:nvSpPr>
+        <p:spPr>
+          <a:xfrm>
+            <a:off x="0" y="0"/>
+            <a:ext cx="12191695" cy="384048"/>
+          </a:xfrm>
+          <a:prstGeom prst="rect">
+            <a:avLst/>
+          </a:prstGeom>
+          <a:solidFill>
+            <a:srgbClr val="72256D"/>
+          </a:solidFill>
+          <a:ln>
+            <a:noFill/>
+          </a:ln>
+        </p:spPr>
+        <p:style>
+          <a:lnRef idx="1">
+            <a:schemeClr val="accent1"/>
+          </a:lnRef>
+          <a:fillRef idx="3">
+            <a:schemeClr val="accent1"/>
+          </a:fillRef>
+          <a:effectRef idx="2">
+            <a:schemeClr val="accent1"/>
+          </a:effectRef>
+          <a:fontRef idx="minor">
+            <a:schemeClr val="lt1"/>
+          </a:fontRef>
+        </p:style>
+        <p:txBody>
+          <a:bodyPr rtlCol="0" anchor="ctr"/>
+          <a:lstStyle/>
+          <a:p>
+            <a:pPr algn="ctr"/>
+          </a:p>
+        </p:txBody>
+      </p:sp>
+      <p:sp>
+        <p:nvSpPr>
+          <p:cNvPr id="3" name="TextBox 2"/>
+          <p:cNvSpPr txBox="1"/>
+          <p:nvPr/>
+        </p:nvSpPr>
+        <p:spPr>
+          <a:xfrm>
+            <a:off x="411480" y="73152"/>
+            <a:ext cx="6858000" cy="228600"/>
+          </a:xfrm>
+          <a:prstGeom prst="rect">
+            <a:avLst/>
+          </a:prstGeom>
+          <a:noFill/>
+        </p:spPr>
+        <p:txBody>
+          <a:bodyPr wrap="none">
+            <a:spAutoFit/>
+          </a:bodyPr>
+          <a:lstStyle/>
+          <a:p>
+            <a:r>
+              <a:rPr sz="900" b="0">
+                <a:solidFill>
+                  <a:srgbClr val="FFFFFF"/>
+                </a:solidFill>
+                <a:latin typeface="Aptos"/>
+              </a:rPr>
+              <a:t>Discussion</a:t>
+            </a:r>
+          </a:p>
+        </p:txBody>
+      </p:sp>
+      <p:sp>
+        <p:nvSpPr>
+          <p:cNvPr id="4" name="TextBox 3"/>
+          <p:cNvSpPr txBox="1"/>
+          <p:nvPr/>
+        </p:nvSpPr>
+        <p:spPr>
+          <a:xfrm>
+            <a:off x="10607040" y="73152"/>
+            <a:ext cx="1097280" cy="228600"/>
+          </a:xfrm>
+          <a:prstGeom prst="rect">
+            <a:avLst/>
+          </a:prstGeom>
+          <a:noFill/>
+        </p:spPr>
+        <p:txBody>
+          <a:bodyPr wrap="none">
+            <a:spAutoFit/>
+          </a:bodyPr>
+          <a:lstStyle/>
+          <a:p>
+            <a:r>
+              <a:rPr sz="900" b="0">
+                <a:solidFill>
+                  <a:srgbClr val="FFFFFF"/>
+                </a:solidFill>
+                <a:latin typeface="Aptos"/>
+              </a:rPr>
+              <a:t>9</a:t>
+            </a:r>
+          </a:p>
+        </p:txBody>
+      </p:sp>
+      <p:sp>
+        <p:nvSpPr>
+          <p:cNvPr id="5" name="TextBox 4"/>
+          <p:cNvSpPr txBox="1"/>
+          <p:nvPr/>
+        </p:nvSpPr>
+        <p:spPr>
+          <a:xfrm>
+            <a:off x="594360" y="658368"/>
+            <a:ext cx="9875520" cy="502920"/>
+          </a:xfrm>
+          <a:prstGeom prst="rect">
+            <a:avLst/>
+          </a:prstGeom>
+          <a:noFill/>
+        </p:spPr>
+        <p:txBody>
+          <a:bodyPr wrap="none">
+            <a:spAutoFit/>
+          </a:bodyPr>
+          <a:lstStyle/>
+          <a:p>
+            <a:r>
+              <a:rPr sz="2800" b="1">
+                <a:solidFill>
+                  <a:srgbClr val="201A2A"/>
+                </a:solidFill>
+                <a:latin typeface="Aptos"/>
+              </a:rPr>
+              <a:t>Limitations and Next Step</a:t>
+            </a:r>
+          </a:p>
+        </p:txBody>
+      </p:sp>
+      <p:sp>
+        <p:nvSpPr>
+          <p:cNvPr id="6" name="TextBox 5"/>
+          <p:cNvSpPr txBox="1"/>
+          <p:nvPr/>
+        </p:nvSpPr>
+        <p:spPr>
+          <a:xfrm>
+            <a:off x="822960" y="1463040"/>
+            <a:ext cx="4937760" cy="3474720"/>
+          </a:xfrm>
+          <a:prstGeom prst="rect">
+            <a:avLst/>
+          </a:prstGeom>
+          <a:noFill/>
+        </p:spPr>
+        <p:txBody>
+          <a:bodyPr wrap="none">
+            <a:spAutoFit/>
+          </a:bodyPr>
+          <a:lstStyle/>
+          <a:p>
+            <a:pPr>
+              <a:defRPr sz="1800">
+                <a:solidFill>
+                  <a:srgbClr val="201A2A"/>
+                </a:solidFill>
+                <a:latin typeface="Aptos"/>
+              </a:defRPr>
+            </a:pPr>
+            <a:r>
+              <a:t>What the evidence does not show</a:t>
+            </a:r>
+          </a:p>
+          <a:p>
+            <a:pPr>
+              <a:defRPr sz="1800">
+                <a:solidFill>
+                  <a:srgbClr val="201A2A"/>
+                </a:solidFill>
+                <a:latin typeface="Aptos"/>
+              </a:defRPr>
+            </a:pPr>
+            <a:r>
+              <a:t>Operational risk or missing validation</a:t>
+            </a:r>
+          </a:p>
+          <a:p>
+            <a:pPr>
+              <a:defRPr sz="1800">
+                <a:solidFill>
+                  <a:srgbClr val="201A2A"/>
+                </a:solidFill>
+                <a:latin typeface="Aptos"/>
+              </a:defRPr>
+            </a:pPr>
+            <a:r>
+              <a:t>Decision, owner, and next artifact</a:t>
+            </a:r>
+          </a:p>
+        </p:txBody>
+      </p:sp>
+      <p:sp>
+        <p:nvSpPr>
+          <p:cNvPr id="7" name="Rounded Rectangle 6"/>
+          <p:cNvSpPr/>
+          <p:nvPr/>
+        </p:nvSpPr>
+        <p:spPr>
+          <a:xfrm>
+            <a:off x="6583680" y="1508760"/>
+            <a:ext cx="4114800" cy="2926080"/>
+          </a:xfrm>
+          <a:prstGeom prst="roundRect">
+            <a:avLst/>
+          </a:prstGeom>
+          <a:solidFill>
+            <a:srgbClr val="F7F0F6"/>
+          </a:solidFill>
+          <a:ln>
+            <a:solidFill>
+              <a:srgbClr val="AA7CA7"/>
+            </a:solidFill>
+          </a:ln>
+        </p:spPr>
+        <p:style>
+          <a:lnRef idx="1">
+            <a:schemeClr val="accent1"/>
+          </a:lnRef>
+          <a:fillRef idx="3">
+            <a:schemeClr val="accent1"/>
+          </a:fillRef>
+          <a:effectRef idx="2">
+            <a:schemeClr val="accent1"/>
+          </a:effectRef>
+          <a:fontRef idx="minor">
+            <a:schemeClr val="lt1"/>
+          </a:fontRef>
+        </p:style>
+        <p:txBody>
+          <a:bodyPr rtlCol="0" anchor="ctr"/>
+          <a:lstStyle/>
+          <a:p>
+            <a:pPr algn="ctr"/>
+          </a:p>
+        </p:txBody>
+      </p:sp>
+      <p:sp>
+        <p:nvSpPr>
+          <p:cNvPr id="8" name="TextBox 7"/>
+          <p:cNvSpPr txBox="1"/>
+          <p:nvPr/>
+        </p:nvSpPr>
+        <p:spPr>
+          <a:xfrm>
+            <a:off x="6812280" y="1737360"/>
+            <a:ext cx="3657600" cy="320040"/>
+          </a:xfrm>
+          <a:prstGeom prst="rect">
+            <a:avLst/>
+          </a:prstGeom>
+          <a:noFill/>
+        </p:spPr>
+        <p:txBody>
+          <a:bodyPr wrap="none">
+            <a:spAutoFit/>
+          </a:bodyPr>
+          <a:lstStyle/>
+          <a:p>
+            <a:r>
+              <a:rPr sz="1500" b="1">
+                <a:solidFill>
+                  <a:srgbClr val="72256D"/>
+                </a:solidFill>
+                <a:latin typeface="Aptos"/>
+              </a:rPr>
+              <a:t>Decision prompt</a:t>
+            </a:r>
+          </a:p>
+        </p:txBody>
+      </p:sp>
+      <p:sp>
+        <p:nvSpPr>
+          <p:cNvPr id="9" name="TextBox 8"/>
+          <p:cNvSpPr txBox="1"/>
+          <p:nvPr/>
+        </p:nvSpPr>
+        <p:spPr>
+          <a:xfrm>
+            <a:off x="6812280" y="2194560"/>
+            <a:ext cx="3657600" cy="2011680"/>
+          </a:xfrm>
+          <a:prstGeom prst="rect">
+            <a:avLst/>
+          </a:prstGeom>
+          <a:noFill/>
+        </p:spPr>
+        <p:txBody>
+          <a:bodyPr wrap="none">
+            <a:spAutoFit/>
+          </a:bodyPr>
+          <a:lstStyle/>
+          <a:p>
+            <a:r>
+              <a:rPr sz="1200" b="0">
+                <a:solidFill>
+                  <a:srgbClr val="201A2A"/>
+                </a:solidFill>
+                <a:latin typeface="Aptos"/>
+              </a:rPr>
+              <a:t>The audience should know what response is needed.</a:t>
             </a:r>
           </a:p>
         </p:txBody>

</xml_diff>